<commit_message>
feat: add Slide 07 — Target Physician Specialties (5-card grid)
Two-column card layout: Orthopedic Surgeon, Cardiologist,
Ward Pharmacist (Tier A) + Internal Medicine, Nephrologist (Tier B).
Insight bar highlights PharmD peer advantage with pharmacists.
Rebuilds full 7-slide PPTX with updated speaker notes.

https://claude.ai/code/session_01Guhi8MhtAfY7CjpWAB7RaT
</commit_message>
<xml_diff>
--- a/projects/Clexane_Interview_Deck_Jan_ppt169_20260615/exports/Clexane_Interview_Deck_Jan.pptx
+++ b/projects/Clexane_Interview_Deck_Jan_ppt169_20260615/exports/Clexane_Interview_Deck_Jan.pptx
@@ -11,6 +11,7 @@
     <p:sldId id="259" r:id="rId10"/>
     <p:sldId id="260" r:id="rId11"/>
     <p:sldId id="261" r:id="rId12"/>
+    <p:sldId id="262" r:id="rId13"/>
   </p:sldIdLst>
   <p:sldSz cx="12192000" cy="6858000" type="screen4x3"/>
   <p:notesSz cx="6858000" cy="9144000"/>
@@ -643,6 +644,119 @@
             <a:r>
               <a:rPr lang="zh-CN" dirty="0"/>
               <a:t>I welcome any questions. And I'm ready.</a:t>
+            </a:r>
+          </a:p>
+        </p:txBody>
+      </p:sp>
+    </p:spTree>
+  </p:cSld>
+  <p:clrMapOvr>
+    <a:masterClrMapping/>
+  </p:clrMapOvr>
+</p:notes>
+</file>
+
+<file path=ppt/notesSlides/notesSlide7.xml><?xml version="1.0" encoding="utf-8"?>
+<p:notes xmlns:a="http://schemas.openxmlformats.org/drawingml/2006/main" xmlns:r="http://schemas.openxmlformats.org/officeDocument/2006/relationships" xmlns:p="http://schemas.openxmlformats.org/presentationml/2006/main">
+  <p:cSld>
+    <p:spTree>
+      <p:nvGrpSpPr>
+        <p:cNvPr id="1" name=""/>
+        <p:cNvGrpSpPr/>
+        <p:nvPr/>
+      </p:nvGrpSpPr>
+      <p:grpSpPr>
+        <a:xfrm>
+          <a:off x="0" y="0"/>
+          <a:ext cx="0" cy="0"/>
+          <a:chOff x="0" y="0"/>
+          <a:chExt cx="0" cy="0"/>
+        </a:xfrm>
+      </p:grpSpPr>
+      <p:sp>
+        <p:nvSpPr>
+          <p:cNvPr id="2" name="Slide Image Placeholder 1"/>
+          <p:cNvSpPr>
+            <a:spLocks noGrp="1" noRot="1" noChangeAspect="1"/>
+          </p:cNvSpPr>
+          <p:nvPr>
+            <p:ph type="sldImg"/>
+          </p:nvPr>
+        </p:nvSpPr>
+        <p:spPr/>
+      </p:sp>
+      <p:sp>
+        <p:nvSpPr>
+          <p:cNvPr id="3" name="Notes Placeholder 2"/>
+          <p:cNvSpPr>
+            <a:spLocks noGrp="1"/>
+          </p:cNvSpPr>
+          <p:nvPr>
+            <p:ph type="body" idx="1"/>
+          </p:nvPr>
+        </p:nvSpPr>
+        <p:spPr/>
+        <p:txBody>
+          <a:bodyPr/>
+          <a:lstStyle/>
+          <a:p>
+            <a:r>
+              <a:rPr lang="zh-CN" dirty="0"/>
+              <a:t>This slide shows you exactly who I plan to call on and why. I've segmented my target physicians into five groups across two tiers.</a:t>
+            </a:r>
+          </a:p>
+          <a:p>
+            <a:endParaRPr lang="zh-CN" dirty="0"/>
+          </a:p>
+          <a:p>
+            <a:r>
+              <a:rPr lang="zh-CN" dirty="0"/>
+              <a:t>Tier A — my highest-priority call targets — are orthopedic surgeons, cardiologists, and ward pharmacists. Orthopedic surgeons at PMK are a natural fit because hip and knee replacement surgery requires post-op VTE prophylaxis, and Clexane is the ACCP-recommended LMWH of choice. My key message to them is simple: predictable dosing, no lab monitoring, and the patient can self-inject at home — which means cleaner discharge planning and less nursing burden.</a:t>
+            </a:r>
+          </a:p>
+          <a:p>
+            <a:endParaRPr lang="zh-CN" dirty="0"/>
+          </a:p>
+          <a:p>
+            <a:r>
+              <a:rPr lang="zh-CN" dirty="0"/>
+              <a:t>Cardiologists are priority A because of the ACS indication. The ESSENCE and TIMI 11B trial data are compelling — Clexane reduced recurrent ischemia versus UFH. I would lead with those trial names and outcomes rather than a generic product pitch.</a:t>
+            </a:r>
+          </a:p>
+          <a:p>
+            <a:endParaRPr lang="zh-CN" dirty="0"/>
+          </a:p>
+          <a:p>
+            <a:r>
+              <a:rPr lang="zh-CN" dirty="0"/>
+              <a:t>Ward pharmacists are a unique call point I want to highlight. As a Pharm.D. myself, I speak their language — PK, dosing adjustment, drug interaction review. Pharmacists often control formulary inclusion and protocol design. Engaging them as clinical partners, not just gatekeepers, multiplies my reach to every physician on the ward.</a:t>
+            </a:r>
+          </a:p>
+          <a:p>
+            <a:endParaRPr lang="zh-CN" dirty="0"/>
+          </a:p>
+          <a:p>
+            <a:r>
+              <a:rPr lang="zh-CN" dirty="0"/>
+              <a:t>Tier B are internal medicine physicians and nephrologists. For internists, my message centers on the MEDENOX trial showing 63% VTE reduction with prophylaxis in acutely ill medical patients. I'll use the Padua Prediction Score as a tool to help them identify eligible patients and link it directly to the Clexane 40 mg protocol.</a:t>
+            </a:r>
+          </a:p>
+          <a:p>
+            <a:endParaRPr lang="zh-CN" dirty="0"/>
+          </a:p>
+          <a:p>
+            <a:r>
+              <a:rPr lang="zh-CN" dirty="0"/>
+              <a:t>For nephrologists, the key is the renal dose-adjustment story — Clexane is usable in CKD down to CrCl 15 with monitoring, which is where DOACs are often contraindicated. I'll address the renal concern proactively rather than waiting for an objection.</a:t>
+            </a:r>
+          </a:p>
+          <a:p>
+            <a:endParaRPr lang="zh-CN" dirty="0"/>
+          </a:p>
+          <a:p>
+            <a:r>
+              <a:rPr lang="zh-CN" dirty="0"/>
+              <a:t>The bottom line on this slide: I know not just who to call, but what clinical problem each specialty is trying to solve, and how Clexane solves it. That's how I turn product knowledge into prescribing behavior.</a:t>
             </a:r>
           </a:p>
         </p:txBody>
@@ -23868,6 +23982,4802 @@
 </p:sld>
 </file>
 
+<file path=ppt/slides/slide7.xml><?xml version="1.0" encoding="utf-8"?>
+<p:sld xmlns:a="http://schemas.openxmlformats.org/drawingml/2006/main" xmlns:r="http://schemas.openxmlformats.org/officeDocument/2006/relationships" xmlns:p="http://schemas.openxmlformats.org/presentationml/2006/main">
+  <p:cSld>
+    <p:spTree>
+      <p:nvGrpSpPr>
+        <p:cNvPr id="1" name=""/>
+        <p:cNvGrpSpPr/>
+        <p:nvPr/>
+      </p:nvGrpSpPr>
+      <p:grpSpPr>
+        <a:xfrm>
+          <a:off x="0" y="0"/>
+          <a:ext cx="0" cy="0"/>
+          <a:chOff x="0" y="0"/>
+          <a:chExt cx="0" cy="0"/>
+        </a:xfrm>
+      </p:grpSpPr>
+      <p:sp>
+        <p:nvSpPr>
+          <p:cNvPr id="2" name="Rectangle 2"/>
+          <p:cNvSpPr/>
+          <p:nvPr/>
+        </p:nvSpPr>
+        <p:spPr>
+          <a:xfrm>
+            <a:off x="0" y="0"/>
+            <a:ext cx="12192000" cy="6858000"/>
+          </a:xfrm>
+          <a:prstGeom prst="rect">
+            <a:avLst/>
+          </a:prstGeom>
+          <a:solidFill>
+            <a:srgbClr val="FFFFFF"/>
+          </a:solidFill>
+          <a:ln>
+            <a:noFill/>
+          </a:ln>
+        </p:spPr>
+      </p:sp>
+      <p:sp>
+        <p:nvSpPr>
+          <p:cNvPr id="3" name="Rectangle 3"/>
+          <p:cNvSpPr/>
+          <p:nvPr/>
+        </p:nvSpPr>
+        <p:spPr>
+          <a:xfrm>
+            <a:off x="0" y="0"/>
+            <a:ext cx="12192000" cy="742950"/>
+          </a:xfrm>
+          <a:prstGeom prst="rect">
+            <a:avLst/>
+          </a:prstGeom>
+          <a:solidFill>
+            <a:srgbClr val="AE232F"/>
+          </a:solidFill>
+          <a:ln>
+            <a:noFill/>
+          </a:ln>
+        </p:spPr>
+      </p:sp>
+      <p:sp>
+        <p:nvSpPr>
+          <p:cNvPr id="4" name="Rectangle 4"/>
+          <p:cNvSpPr/>
+          <p:nvPr/>
+        </p:nvSpPr>
+        <p:spPr>
+          <a:xfrm>
+            <a:off x="266700" y="171450"/>
+            <a:ext cx="304800" cy="304800"/>
+          </a:xfrm>
+          <a:prstGeom prst="roundRect">
+            <a:avLst>
+              <a:gd name="adj" fmla="val 18750"/>
+            </a:avLst>
+          </a:prstGeom>
+          <a:solidFill>
+            <a:srgbClr val="8A1B25"/>
+          </a:solidFill>
+          <a:ln>
+            <a:noFill/>
+          </a:ln>
+        </p:spPr>
+      </p:sp>
+      <p:sp>
+        <p:nvSpPr>
+          <p:cNvPr id="5" name="TextBox 5"/>
+          <p:cNvSpPr txBox="1"/>
+          <p:nvPr/>
+        </p:nvSpPr>
+        <p:spPr>
+          <a:xfrm>
+            <a:off x="318177" y="250031"/>
+            <a:ext cx="201847" cy="228600"/>
+          </a:xfrm>
+          <a:prstGeom prst="rect">
+            <a:avLst/>
+          </a:prstGeom>
+          <a:noFill/>
+          <a:ln>
+            <a:noFill/>
+          </a:ln>
+        </p:spPr>
+        <p:txBody>
+          <a:bodyPr wrap="none" lIns="0" tIns="0" rIns="0" bIns="0" anchor="t" anchorCtr="0">
+            <a:spAutoFit/>
+          </a:bodyPr>
+          <a:lstStyle/>
+          <a:p>
+            <a:pPr algn="ctr"/>
+            <a:r>
+              <a:rPr lang="zh-CN" sz="1125" b="1" dirty="0">
+                <a:solidFill>
+                  <a:srgbClr val="FFFFFF"/>
+                </a:solidFill>
+                <a:latin typeface="Arial"/>
+                <a:ea typeface="Microsoft YaHei"/>
+                <a:cs typeface="Arial"/>
+              </a:rPr>
+              <a:t>07</a:t>
+            </a:r>
+          </a:p>
+        </p:txBody>
+      </p:sp>
+      <p:sp>
+        <p:nvSpPr>
+          <p:cNvPr id="6" name="TextBox 6"/>
+          <p:cNvSpPr txBox="1"/>
+          <p:nvPr/>
+        </p:nvSpPr>
+        <p:spPr>
+          <a:xfrm>
+            <a:off x="718185" y="208598"/>
+            <a:ext cx="5742292" cy="396240"/>
+          </a:xfrm>
+          <a:prstGeom prst="rect">
+            <a:avLst/>
+          </a:prstGeom>
+          <a:noFill/>
+          <a:ln>
+            <a:noFill/>
+          </a:ln>
+        </p:spPr>
+        <p:txBody>
+          <a:bodyPr wrap="none" lIns="0" tIns="0" rIns="0" bIns="0" anchor="t" anchorCtr="0">
+            <a:spAutoFit/>
+          </a:bodyPr>
+          <a:lstStyle/>
+          <a:p>
+            <a:pPr algn="l"/>
+            <a:r>
+              <a:rPr lang="zh-CN" sz="1950" b="1" dirty="0">
+                <a:solidFill>
+                  <a:srgbClr val="FFFFFF"/>
+                </a:solidFill>
+                <a:latin typeface="Arial"/>
+                <a:ea typeface="Microsoft YaHei"/>
+                <a:cs typeface="Arial"/>
+              </a:rPr>
+              <a:t>Who I Call On — Target Physician Specialties</a:t>
+            </a:r>
+          </a:p>
+        </p:txBody>
+      </p:sp>
+      <p:sp>
+        <p:nvSpPr>
+          <p:cNvPr id="7" name="TextBox 7"/>
+          <p:cNvSpPr txBox="1"/>
+          <p:nvPr/>
+        </p:nvSpPr>
+        <p:spPr>
+          <a:xfrm>
+            <a:off x="730568" y="504349"/>
+            <a:ext cx="5179909" cy="198120"/>
+          </a:xfrm>
+          <a:prstGeom prst="rect">
+            <a:avLst/>
+          </a:prstGeom>
+          <a:noFill/>
+          <a:ln>
+            <a:noFill/>
+          </a:ln>
+        </p:spPr>
+        <p:txBody>
+          <a:bodyPr wrap="none" lIns="0" tIns="0" rIns="0" bIns="0" anchor="t" anchorCtr="0">
+            <a:spAutoFit/>
+          </a:bodyPr>
+          <a:lstStyle/>
+          <a:p>
+            <a:pPr algn="l"/>
+            <a:r>
+              <a:rPr lang="zh-CN" sz="975" dirty="0">
+                <a:solidFill>
+                  <a:srgbClr val="F9E5E7"/>
+                </a:solidFill>
+                <a:latin typeface="Arial"/>
+                <a:ea typeface="Microsoft YaHei"/>
+                <a:cs typeface="Arial"/>
+              </a:rPr>
+              <a:t>Five key stakeholder groups · Tier A priority calls · Clinical partnership approach</a:t>
+            </a:r>
+          </a:p>
+        </p:txBody>
+      </p:sp>
+      <p:grpSp>
+        <p:nvGrpSpPr>
+          <p:cNvPr id="22" name="Group 22"/>
+          <p:cNvGrpSpPr/>
+          <p:nvPr/>
+        </p:nvGrpSpPr>
+        <p:grpSpPr>
+          <a:xfrm>
+            <a:off x="342900" y="876300"/>
+            <a:ext cx="6085523" cy="1600200"/>
+            <a:chOff x="342900" y="876300"/>
+            <a:chExt cx="6085523" cy="1600200"/>
+          </a:xfrm>
+          <a:effectLst>
+            <a:outerShdw blurRad="76200" dist="19050" dir="5400000" algn="ctr" rotWithShape="0">
+              <a:srgbClr val="000000">
+                <a:alpha val="5250"/>
+              </a:srgbClr>
+            </a:outerShdw>
+          </a:effectLst>
+        </p:grpSpPr>
+        <p:sp>
+          <p:nvSpPr>
+            <p:cNvPr id="8" name="Rectangle 8"/>
+            <p:cNvSpPr/>
+            <p:nvPr/>
+          </p:nvSpPr>
+          <p:spPr>
+            <a:xfrm>
+              <a:off x="342900" y="876300"/>
+              <a:ext cx="5695950" cy="1600200"/>
+            </a:xfrm>
+            <a:prstGeom prst="roundRect">
+              <a:avLst>
+                <a:gd name="adj" fmla="val 4762"/>
+              </a:avLst>
+            </a:prstGeom>
+            <a:solidFill>
+              <a:srgbClr val="FFFFFF"/>
+            </a:solidFill>
+            <a:ln w="9525">
+              <a:solidFill>
+                <a:srgbClr val="E0E0E0"/>
+              </a:solidFill>
+            </a:ln>
+            <a:effectLst>
+              <a:outerShdw blurRad="76200" dist="19050" dir="5400000" algn="ctr" rotWithShape="0">
+                <a:srgbClr val="000000">
+                  <a:alpha val="5250"/>
+                </a:srgbClr>
+              </a:outerShdw>
+            </a:effectLst>
+          </p:spPr>
+        </p:sp>
+        <p:sp>
+          <p:nvSpPr>
+            <p:cNvPr id="9" name="Rectangle 9"/>
+            <p:cNvSpPr/>
+            <p:nvPr/>
+          </p:nvSpPr>
+          <p:spPr>
+            <a:xfrm>
+              <a:off x="342900" y="876300"/>
+              <a:ext cx="47625" cy="1600200"/>
+            </a:xfrm>
+            <a:prstGeom prst="roundRect">
+              <a:avLst>
+                <a:gd name="adj" fmla="val 50000"/>
+              </a:avLst>
+            </a:prstGeom>
+            <a:solidFill>
+              <a:srgbClr val="AE232F"/>
+            </a:solidFill>
+            <a:ln>
+              <a:noFill/>
+            </a:ln>
+            <a:effectLst>
+              <a:outerShdw blurRad="76200" dist="19050" dir="5400000" algn="ctr" rotWithShape="0">
+                <a:srgbClr val="000000">
+                  <a:alpha val="5250"/>
+                </a:srgbClr>
+              </a:outerShdw>
+            </a:effectLst>
+          </p:spPr>
+        </p:sp>
+        <p:sp>
+          <p:nvSpPr>
+            <p:cNvPr id="10" name="Rectangle 10"/>
+            <p:cNvSpPr/>
+            <p:nvPr/>
+          </p:nvSpPr>
+          <p:spPr>
+            <a:xfrm>
+              <a:off x="5467350" y="952500"/>
+              <a:ext cx="457200" cy="209550"/>
+            </a:xfrm>
+            <a:prstGeom prst="roundRect">
+              <a:avLst>
+                <a:gd name="adj" fmla="val 18182"/>
+              </a:avLst>
+            </a:prstGeom>
+            <a:solidFill>
+              <a:srgbClr val="AE232F"/>
+            </a:solidFill>
+            <a:ln>
+              <a:noFill/>
+            </a:ln>
+            <a:effectLst>
+              <a:outerShdw blurRad="76200" dist="19050" dir="5400000" algn="ctr" rotWithShape="0">
+                <a:srgbClr val="000000">
+                  <a:alpha val="5250"/>
+                </a:srgbClr>
+              </a:outerShdw>
+            </a:effectLst>
+          </p:spPr>
+        </p:sp>
+        <p:sp>
+          <p:nvSpPr>
+            <p:cNvPr id="11" name="TextBox 11"/>
+            <p:cNvSpPr txBox="1"/>
+            <p:nvPr/>
+          </p:nvSpPr>
+          <p:spPr>
+            <a:xfrm>
+              <a:off x="5523752" y="1006316"/>
+              <a:ext cx="344395" cy="167640"/>
+            </a:xfrm>
+            <a:prstGeom prst="rect">
+              <a:avLst/>
+            </a:prstGeom>
+            <a:noFill/>
+            <a:ln>
+              <a:noFill/>
+            </a:ln>
+            <a:effectLst>
+              <a:outerShdw blurRad="76200" dist="19050" dir="5400000" algn="ctr" rotWithShape="0">
+                <a:srgbClr val="000000">
+                  <a:alpha val="5250"/>
+                </a:srgbClr>
+              </a:outerShdw>
+            </a:effectLst>
+          </p:spPr>
+          <p:txBody>
+            <a:bodyPr wrap="none" lIns="0" tIns="0" rIns="0" bIns="0" anchor="t" anchorCtr="0">
+              <a:spAutoFit/>
+            </a:bodyPr>
+            <a:lstStyle/>
+            <a:p>
+              <a:pPr algn="ctr"/>
+              <a:r>
+                <a:rPr lang="zh-CN" sz="825" b="1" dirty="0">
+                  <a:solidFill>
+                    <a:srgbClr val="FFFFFF"/>
+                  </a:solidFill>
+                  <a:latin typeface="Arial"/>
+                  <a:ea typeface="Microsoft YaHei"/>
+                  <a:cs typeface="Arial"/>
+                </a:rPr>
+                <a:t>Tier A</a:t>
+              </a:r>
+            </a:p>
+          </p:txBody>
+        </p:sp>
+        <p:sp>
+          <p:nvSpPr>
+            <p:cNvPr id="12" name="Ellipse 12"/>
+            <p:cNvSpPr/>
+            <p:nvPr/>
+          </p:nvSpPr>
+          <p:spPr>
+            <a:xfrm>
+              <a:off x="476250" y="990600"/>
+              <a:ext cx="419100" cy="419100"/>
+            </a:xfrm>
+            <a:prstGeom prst="ellipse">
+              <a:avLst/>
+            </a:prstGeom>
+            <a:solidFill>
+              <a:srgbClr val="F9E5E7"/>
+            </a:solidFill>
+            <a:ln>
+              <a:noFill/>
+            </a:ln>
+            <a:effectLst>
+              <a:outerShdw blurRad="76200" dist="19050" dir="5400000" algn="ctr" rotWithShape="0">
+                <a:srgbClr val="000000">
+                  <a:alpha val="5250"/>
+                </a:srgbClr>
+              </a:outerShdw>
+            </a:effectLst>
+          </p:spPr>
+        </p:sp>
+        <p:sp>
+          <p:nvSpPr>
+            <p:cNvPr id="13" name="Freeform 13"/>
+            <p:cNvSpPr/>
+            <p:nvPr/>
+          </p:nvSpPr>
+          <p:spPr>
+            <a:xfrm>
+              <a:off x="590550" y="1104900"/>
+              <a:ext cx="190500" cy="190500"/>
+            </a:xfrm>
+            <a:custGeom>
+              <a:avLst/>
+              <a:gdLst/>
+              <a:ahLst/>
+              <a:cxnLst/>
+              <a:rect l="l" t="t" r="r" b="b"/>
+              <a:pathLst>
+                <a:path w="190500" h="190500">
+                  <a:moveTo>
+                    <a:pt x="95250" y="0"/>
+                  </a:moveTo>
+                  <a:cubicBezTo>
+                    <a:pt x="147857" y="0"/>
+                    <a:pt x="190500" y="42643"/>
+                    <a:pt x="190500" y="95250"/>
+                  </a:cubicBezTo>
+                  <a:cubicBezTo>
+                    <a:pt x="190500" y="147855"/>
+                    <a:pt x="147855" y="190500"/>
+                    <a:pt x="95250" y="190500"/>
+                  </a:cubicBezTo>
+                  <a:cubicBezTo>
+                    <a:pt x="42645" y="190500"/>
+                    <a:pt x="0" y="147855"/>
+                    <a:pt x="0" y="95250"/>
+                  </a:cubicBezTo>
+                  <a:lnTo>
+                    <a:pt x="38" y="92583"/>
+                  </a:lnTo>
+                  <a:cubicBezTo>
+                    <a:pt x="1448" y="41215"/>
+                    <a:pt x="43529" y="0"/>
+                    <a:pt x="95250" y="0"/>
+                  </a:cubicBezTo>
+                  <a:moveTo>
+                    <a:pt x="114300" y="47625"/>
+                  </a:moveTo>
+                  <a:cubicBezTo>
+                    <a:pt x="109039" y="47625"/>
+                    <a:pt x="104775" y="51889"/>
+                    <a:pt x="104775" y="57150"/>
+                  </a:cubicBezTo>
+                  <a:lnTo>
+                    <a:pt x="104775" y="85715"/>
+                  </a:lnTo>
+                  <a:lnTo>
+                    <a:pt x="85725" y="85715"/>
+                  </a:lnTo>
+                  <a:lnTo>
+                    <a:pt x="85725" y="57150"/>
+                  </a:lnTo>
+                  <a:cubicBezTo>
+                    <a:pt x="85724" y="52321"/>
+                    <a:pt x="82110" y="48257"/>
+                    <a:pt x="77314" y="47692"/>
+                  </a:cubicBezTo>
+                  <a:lnTo>
+                    <a:pt x="76200" y="47625"/>
+                  </a:lnTo>
+                  <a:cubicBezTo>
+                    <a:pt x="70939" y="47625"/>
+                    <a:pt x="66675" y="51889"/>
+                    <a:pt x="66675" y="57150"/>
+                  </a:cubicBezTo>
+                  <a:lnTo>
+                    <a:pt x="66675" y="133350"/>
+                  </a:lnTo>
+                  <a:cubicBezTo>
+                    <a:pt x="66675" y="138611"/>
+                    <a:pt x="70939" y="142875"/>
+                    <a:pt x="76200" y="142875"/>
+                  </a:cubicBezTo>
+                  <a:cubicBezTo>
+                    <a:pt x="81461" y="142875"/>
+                    <a:pt x="85725" y="138611"/>
+                    <a:pt x="85725" y="133350"/>
+                  </a:cubicBezTo>
+                  <a:lnTo>
+                    <a:pt x="85725" y="104765"/>
+                  </a:lnTo>
+                  <a:lnTo>
+                    <a:pt x="104775" y="104765"/>
+                  </a:lnTo>
+                  <a:lnTo>
+                    <a:pt x="104775" y="133350"/>
+                  </a:lnTo>
+                  <a:cubicBezTo>
+                    <a:pt x="104776" y="138179"/>
+                    <a:pt x="108390" y="142243"/>
+                    <a:pt x="113186" y="142808"/>
+                  </a:cubicBezTo>
+                  <a:lnTo>
+                    <a:pt x="114300" y="142875"/>
+                  </a:lnTo>
+                  <a:cubicBezTo>
+                    <a:pt x="119561" y="142875"/>
+                    <a:pt x="123825" y="138611"/>
+                    <a:pt x="123825" y="133350"/>
+                  </a:cubicBezTo>
+                  <a:lnTo>
+                    <a:pt x="123825" y="57150"/>
+                  </a:lnTo>
+                  <a:cubicBezTo>
+                    <a:pt x="123825" y="51889"/>
+                    <a:pt x="119561" y="47625"/>
+                    <a:pt x="114300" y="47625"/>
+                  </a:cubicBezTo>
+                </a:path>
+              </a:pathLst>
+            </a:custGeom>
+            <a:solidFill>
+              <a:srgbClr val="AE232F"/>
+            </a:solidFill>
+            <a:ln>
+              <a:noFill/>
+            </a:ln>
+            <a:effectLst>
+              <a:outerShdw blurRad="76200" dist="19050" dir="5400000" algn="ctr" rotWithShape="0">
+                <a:srgbClr val="000000">
+                  <a:alpha val="5250"/>
+                </a:srgbClr>
+              </a:outerShdw>
+            </a:effectLst>
+          </p:spPr>
+        </p:sp>
+        <p:sp>
+          <p:nvSpPr>
+            <p:cNvPr id="14" name="TextBox 14"/>
+            <p:cNvSpPr txBox="1"/>
+            <p:nvPr/>
+          </p:nvSpPr>
+          <p:spPr>
+            <a:xfrm>
+              <a:off x="995362" y="1021556"/>
+              <a:ext cx="1540764" cy="228600"/>
+            </a:xfrm>
+            <a:prstGeom prst="rect">
+              <a:avLst/>
+            </a:prstGeom>
+            <a:noFill/>
+            <a:ln>
+              <a:noFill/>
+            </a:ln>
+            <a:effectLst>
+              <a:outerShdw blurRad="76200" dist="19050" dir="5400000" algn="ctr" rotWithShape="0">
+                <a:srgbClr val="000000">
+                  <a:alpha val="5250"/>
+                </a:srgbClr>
+              </a:outerShdw>
+            </a:effectLst>
+          </p:spPr>
+          <p:txBody>
+            <a:bodyPr wrap="none" lIns="0" tIns="0" rIns="0" bIns="0" anchor="t" anchorCtr="0">
+              <a:spAutoFit/>
+            </a:bodyPr>
+            <a:lstStyle/>
+            <a:p>
+              <a:pPr algn="l"/>
+              <a:r>
+                <a:rPr lang="zh-CN" sz="1125" b="1" dirty="0">
+                  <a:solidFill>
+                    <a:srgbClr val="1A1A1A"/>
+                  </a:solidFill>
+                  <a:latin typeface="Arial"/>
+                  <a:ea typeface="Microsoft YaHei"/>
+                  <a:cs typeface="Arial"/>
+                </a:rPr>
+                <a:t>Orthopedic Surgeon</a:t>
+              </a:r>
+            </a:p>
+          </p:txBody>
+        </p:sp>
+        <p:sp>
+          <p:nvSpPr>
+            <p:cNvPr id="15" name="TextBox 15"/>
+            <p:cNvSpPr txBox="1"/>
+            <p:nvPr/>
+          </p:nvSpPr>
+          <p:spPr>
+            <a:xfrm>
+              <a:off x="999172" y="1225391"/>
+              <a:ext cx="3740520" cy="167640"/>
+            </a:xfrm>
+            <a:prstGeom prst="rect">
+              <a:avLst/>
+            </a:prstGeom>
+            <a:noFill/>
+            <a:ln>
+              <a:noFill/>
+            </a:ln>
+            <a:effectLst>
+              <a:outerShdw blurRad="76200" dist="19050" dir="5400000" algn="ctr" rotWithShape="0">
+                <a:srgbClr val="000000">
+                  <a:alpha val="5250"/>
+                </a:srgbClr>
+              </a:outerShdw>
+            </a:effectLst>
+          </p:spPr>
+          <p:txBody>
+            <a:bodyPr wrap="none" lIns="0" tIns="0" rIns="0" bIns="0" anchor="t" anchorCtr="0">
+              <a:spAutoFit/>
+            </a:bodyPr>
+            <a:lstStyle/>
+            <a:p>
+              <a:pPr algn="l"/>
+              <a:r>
+                <a:rPr lang="zh-CN" sz="825" b="1" dirty="0">
+                  <a:solidFill>
+                    <a:srgbClr val="AE232F"/>
+                  </a:solidFill>
+                  <a:latin typeface="Arial"/>
+                  <a:ea typeface="Microsoft YaHei"/>
+                  <a:cs typeface="Arial"/>
+                </a:rPr>
+                <a:t>Clexane role: DVT prophylaxis post Hip &amp; Knee Replacement surgery</a:t>
+              </a:r>
+            </a:p>
+          </p:txBody>
+        </p:sp>
+        <p:sp>
+          <p:nvSpPr>
+            <p:cNvPr id="16" name="Line 16"/>
+            <p:cNvSpPr/>
+            <p:nvPr/>
+          </p:nvSpPr>
+          <p:spPr>
+            <a:xfrm>
+              <a:off x="476250" y="1438275"/>
+              <a:ext cx="5448300" cy="9525"/>
+            </a:xfrm>
+            <a:custGeom>
+              <a:avLst/>
+              <a:gdLst/>
+              <a:ahLst/>
+              <a:cxnLst/>
+              <a:rect l="l" t="t" r="r" b="b"/>
+              <a:pathLst>
+                <a:path w="5448300" h="9525">
+                  <a:moveTo>
+                    <a:pt x="0" y="0"/>
+                  </a:moveTo>
+                  <a:lnTo>
+                    <a:pt x="5448300" y="0"/>
+                  </a:lnTo>
+                </a:path>
+              </a:pathLst>
+            </a:custGeom>
+            <a:noFill/>
+            <a:ln w="9525">
+              <a:solidFill>
+                <a:srgbClr val="F5F5F5"/>
+              </a:solidFill>
+            </a:ln>
+          </p:spPr>
+        </p:sp>
+        <p:sp>
+          <p:nvSpPr>
+            <p:cNvPr id="17" name="TextBox 17"/>
+            <p:cNvSpPr txBox="1"/>
+            <p:nvPr/>
+          </p:nvSpPr>
+          <p:spPr>
+            <a:xfrm>
+              <a:off x="464820" y="1503045"/>
+              <a:ext cx="848263" cy="182880"/>
+            </a:xfrm>
+            <a:prstGeom prst="rect">
+              <a:avLst/>
+            </a:prstGeom>
+            <a:noFill/>
+            <a:ln>
+              <a:noFill/>
+            </a:ln>
+            <a:effectLst>
+              <a:outerShdw blurRad="76200" dist="19050" dir="5400000" algn="ctr" rotWithShape="0">
+                <a:srgbClr val="000000">
+                  <a:alpha val="5250"/>
+                </a:srgbClr>
+              </a:outerShdw>
+            </a:effectLst>
+          </p:spPr>
+          <p:txBody>
+            <a:bodyPr wrap="none" lIns="0" tIns="0" rIns="0" bIns="0" anchor="t" anchorCtr="0">
+              <a:spAutoFit/>
+            </a:bodyPr>
+            <a:lstStyle/>
+            <a:p>
+              <a:pPr algn="l"/>
+              <a:r>
+                <a:rPr lang="zh-CN" sz="900" b="1" dirty="0">
+                  <a:solidFill>
+                    <a:srgbClr val="555555"/>
+                  </a:solidFill>
+                  <a:latin typeface="Arial"/>
+                  <a:ea typeface="Microsoft YaHei"/>
+                  <a:cs typeface="Arial"/>
+                </a:rPr>
+                <a:t>Key message:</a:t>
+              </a:r>
+            </a:p>
+          </p:txBody>
+        </p:sp>
+        <p:sp>
+          <p:nvSpPr>
+            <p:cNvPr id="18" name="TextBox 18"/>
+            <p:cNvSpPr txBox="1"/>
+            <p:nvPr/>
+          </p:nvSpPr>
+          <p:spPr>
+            <a:xfrm>
+              <a:off x="464820" y="1674495"/>
+              <a:ext cx="5285518" cy="182880"/>
+            </a:xfrm>
+            <a:prstGeom prst="rect">
+              <a:avLst/>
+            </a:prstGeom>
+            <a:noFill/>
+            <a:ln>
+              <a:noFill/>
+            </a:ln>
+            <a:effectLst>
+              <a:outerShdw blurRad="76200" dist="19050" dir="5400000" algn="ctr" rotWithShape="0">
+                <a:srgbClr val="000000">
+                  <a:alpha val="5250"/>
+                </a:srgbClr>
+              </a:outerShdw>
+            </a:effectLst>
+          </p:spPr>
+          <p:txBody>
+            <a:bodyPr wrap="none" lIns="0" tIns="0" rIns="0" bIns="0" anchor="t" anchorCtr="0">
+              <a:spAutoFit/>
+            </a:bodyPr>
+            <a:lstStyle/>
+            <a:p>
+              <a:pPr algn="l"/>
+              <a:r>
+                <a:rPr lang="zh-CN" sz="900" dirty="0">
+                  <a:solidFill>
+                    <a:srgbClr val="555555"/>
+                  </a:solidFill>
+                  <a:latin typeface="Arial"/>
+                  <a:ea typeface="Microsoft YaHei"/>
+                  <a:cs typeface="Arial"/>
+                </a:rPr>
+                <a:t>Predictable dosing, no aPTT monitoring — patient can self-inject at home after discharge.</a:t>
+              </a:r>
+            </a:p>
+          </p:txBody>
+        </p:sp>
+        <p:sp>
+          <p:nvSpPr>
+            <p:cNvPr id="19" name="TextBox 19"/>
+            <p:cNvSpPr txBox="1"/>
+            <p:nvPr/>
+          </p:nvSpPr>
+          <p:spPr>
+            <a:xfrm>
+              <a:off x="464820" y="1826895"/>
+              <a:ext cx="4577429" cy="182880"/>
+            </a:xfrm>
+            <a:prstGeom prst="rect">
+              <a:avLst/>
+            </a:prstGeom>
+            <a:noFill/>
+            <a:ln>
+              <a:noFill/>
+            </a:ln>
+            <a:effectLst>
+              <a:outerShdw blurRad="76200" dist="19050" dir="5400000" algn="ctr" rotWithShape="0">
+                <a:srgbClr val="000000">
+                  <a:alpha val="5250"/>
+                </a:srgbClr>
+              </a:outerShdw>
+            </a:effectLst>
+          </p:spPr>
+          <p:txBody>
+            <a:bodyPr wrap="none" lIns="0" tIns="0" rIns="0" bIns="0" anchor="t" anchorCtr="0">
+              <a:spAutoFit/>
+            </a:bodyPr>
+            <a:lstStyle/>
+            <a:p>
+              <a:pPr algn="l"/>
+              <a:r>
+                <a:rPr lang="zh-CN" sz="900" dirty="0">
+                  <a:solidFill>
+                    <a:srgbClr val="555555"/>
+                  </a:solidFill>
+                  <a:latin typeface="Arial"/>
+                  <a:ea typeface="Microsoft YaHei"/>
+                  <a:cs typeface="Arial"/>
+                </a:rPr>
+                <a:t>Reduces nursing burden and enables same-day or next-day discharge planning.</a:t>
+              </a:r>
+            </a:p>
+          </p:txBody>
+        </p:sp>
+        <p:sp>
+          <p:nvSpPr>
+            <p:cNvPr id="20" name="TextBox 20"/>
+            <p:cNvSpPr txBox="1"/>
+            <p:nvPr/>
+          </p:nvSpPr>
+          <p:spPr>
+            <a:xfrm>
+              <a:off x="464820" y="1998345"/>
+              <a:ext cx="4787456" cy="182880"/>
+            </a:xfrm>
+            <a:prstGeom prst="rect">
+              <a:avLst/>
+            </a:prstGeom>
+            <a:noFill/>
+            <a:ln>
+              <a:noFill/>
+            </a:ln>
+            <a:effectLst>
+              <a:outerShdw blurRad="76200" dist="19050" dir="5400000" algn="ctr" rotWithShape="0">
+                <a:srgbClr val="000000">
+                  <a:alpha val="5250"/>
+                </a:srgbClr>
+              </a:outerShdw>
+            </a:effectLst>
+          </p:spPr>
+          <p:txBody>
+            <a:bodyPr wrap="none" lIns="0" tIns="0" rIns="0" bIns="0" anchor="t" anchorCtr="0">
+              <a:spAutoFit/>
+            </a:bodyPr>
+            <a:lstStyle/>
+            <a:p>
+              <a:pPr algn="l"/>
+              <a:r>
+                <a:rPr lang="zh-CN" sz="900" dirty="0">
+                  <a:solidFill>
+                    <a:srgbClr val="555555"/>
+                  </a:solidFill>
+                  <a:latin typeface="Arial"/>
+                  <a:ea typeface="Microsoft YaHei"/>
+                  <a:cs typeface="Arial"/>
+                </a:rPr>
+                <a:t>Clinical guideline: ACCP 2022 — LMWH preferred over UFH for hip/knee prophylaxis.</a:t>
+              </a:r>
+            </a:p>
+          </p:txBody>
+        </p:sp>
+        <p:sp>
+          <p:nvSpPr>
+            <p:cNvPr id="21" name="TextBox 21"/>
+            <p:cNvSpPr txBox="1"/>
+            <p:nvPr/>
+          </p:nvSpPr>
+          <p:spPr>
+            <a:xfrm>
+              <a:off x="464820" y="2169795"/>
+              <a:ext cx="5963603" cy="182880"/>
+            </a:xfrm>
+            <a:prstGeom prst="rect">
+              <a:avLst/>
+            </a:prstGeom>
+            <a:noFill/>
+            <a:ln>
+              <a:noFill/>
+            </a:ln>
+            <a:effectLst>
+              <a:outerShdw blurRad="76200" dist="19050" dir="5400000" algn="ctr" rotWithShape="0">
+                <a:srgbClr val="000000">
+                  <a:alpha val="5250"/>
+                </a:srgbClr>
+              </a:outerShdw>
+            </a:effectLst>
+          </p:spPr>
+          <p:txBody>
+            <a:bodyPr wrap="none" lIns="0" tIns="0" rIns="0" bIns="0" anchor="t" anchorCtr="0">
+              <a:spAutoFit/>
+            </a:bodyPr>
+            <a:lstStyle/>
+            <a:p>
+              <a:pPr algn="l"/>
+              <a:r>
+                <a:rPr lang="zh-CN" sz="900" dirty="0">
+                  <a:solidFill>
+                    <a:srgbClr val="555555"/>
+                  </a:solidFill>
+                  <a:latin typeface="Arial"/>
+                  <a:ea typeface="Microsoft YaHei"/>
+                  <a:cs typeface="Arial"/>
+                </a:rPr>
+                <a:t>Duration: 10–14 days (knee) or up to 35 days (hip) — extended outpatient use fits Clexane perfectly.</a:t>
+              </a:r>
+            </a:p>
+          </p:txBody>
+        </p:sp>
+      </p:grpSp>
+      <p:grpSp>
+        <p:nvGrpSpPr>
+          <p:cNvPr id="37" name="Group 37"/>
+          <p:cNvGrpSpPr/>
+          <p:nvPr/>
+        </p:nvGrpSpPr>
+        <p:grpSpPr>
+          <a:xfrm>
+            <a:off x="342900" y="2590800"/>
+            <a:ext cx="5695950" cy="1600200"/>
+            <a:chOff x="342900" y="2590800"/>
+            <a:chExt cx="5695950" cy="1600200"/>
+          </a:xfrm>
+          <a:effectLst>
+            <a:outerShdw blurRad="76200" dist="19050" dir="5400000" algn="ctr" rotWithShape="0">
+              <a:srgbClr val="000000">
+                <a:alpha val="5250"/>
+              </a:srgbClr>
+            </a:outerShdw>
+          </a:effectLst>
+        </p:grpSpPr>
+        <p:sp>
+          <p:nvSpPr>
+            <p:cNvPr id="23" name="Rectangle 23"/>
+            <p:cNvSpPr/>
+            <p:nvPr/>
+          </p:nvSpPr>
+          <p:spPr>
+            <a:xfrm>
+              <a:off x="342900" y="2590800"/>
+              <a:ext cx="5695950" cy="1600200"/>
+            </a:xfrm>
+            <a:prstGeom prst="roundRect">
+              <a:avLst>
+                <a:gd name="adj" fmla="val 4762"/>
+              </a:avLst>
+            </a:prstGeom>
+            <a:solidFill>
+              <a:srgbClr val="FFFFFF"/>
+            </a:solidFill>
+            <a:ln w="9525">
+              <a:solidFill>
+                <a:srgbClr val="E0E0E0"/>
+              </a:solidFill>
+            </a:ln>
+            <a:effectLst>
+              <a:outerShdw blurRad="76200" dist="19050" dir="5400000" algn="ctr" rotWithShape="0">
+                <a:srgbClr val="000000">
+                  <a:alpha val="5250"/>
+                </a:srgbClr>
+              </a:outerShdw>
+            </a:effectLst>
+          </p:spPr>
+        </p:sp>
+        <p:sp>
+          <p:nvSpPr>
+            <p:cNvPr id="24" name="Rectangle 24"/>
+            <p:cNvSpPr/>
+            <p:nvPr/>
+          </p:nvSpPr>
+          <p:spPr>
+            <a:xfrm>
+              <a:off x="342900" y="2590800"/>
+              <a:ext cx="47625" cy="1600200"/>
+            </a:xfrm>
+            <a:prstGeom prst="roundRect">
+              <a:avLst>
+                <a:gd name="adj" fmla="val 50000"/>
+              </a:avLst>
+            </a:prstGeom>
+            <a:solidFill>
+              <a:srgbClr val="AE232F"/>
+            </a:solidFill>
+            <a:ln>
+              <a:noFill/>
+            </a:ln>
+            <a:effectLst>
+              <a:outerShdw blurRad="76200" dist="19050" dir="5400000" algn="ctr" rotWithShape="0">
+                <a:srgbClr val="000000">
+                  <a:alpha val="5250"/>
+                </a:srgbClr>
+              </a:outerShdw>
+            </a:effectLst>
+          </p:spPr>
+        </p:sp>
+        <p:sp>
+          <p:nvSpPr>
+            <p:cNvPr id="25" name="Rectangle 25"/>
+            <p:cNvSpPr/>
+            <p:nvPr/>
+          </p:nvSpPr>
+          <p:spPr>
+            <a:xfrm>
+              <a:off x="5467350" y="2667000"/>
+              <a:ext cx="457200" cy="209550"/>
+            </a:xfrm>
+            <a:prstGeom prst="roundRect">
+              <a:avLst>
+                <a:gd name="adj" fmla="val 18182"/>
+              </a:avLst>
+            </a:prstGeom>
+            <a:solidFill>
+              <a:srgbClr val="AE232F"/>
+            </a:solidFill>
+            <a:ln>
+              <a:noFill/>
+            </a:ln>
+            <a:effectLst>
+              <a:outerShdw blurRad="76200" dist="19050" dir="5400000" algn="ctr" rotWithShape="0">
+                <a:srgbClr val="000000">
+                  <a:alpha val="5250"/>
+                </a:srgbClr>
+              </a:outerShdw>
+            </a:effectLst>
+          </p:spPr>
+        </p:sp>
+        <p:sp>
+          <p:nvSpPr>
+            <p:cNvPr id="26" name="TextBox 26"/>
+            <p:cNvSpPr txBox="1"/>
+            <p:nvPr/>
+          </p:nvSpPr>
+          <p:spPr>
+            <a:xfrm>
+              <a:off x="5523752" y="2720816"/>
+              <a:ext cx="344395" cy="167640"/>
+            </a:xfrm>
+            <a:prstGeom prst="rect">
+              <a:avLst/>
+            </a:prstGeom>
+            <a:noFill/>
+            <a:ln>
+              <a:noFill/>
+            </a:ln>
+            <a:effectLst>
+              <a:outerShdw blurRad="76200" dist="19050" dir="5400000" algn="ctr" rotWithShape="0">
+                <a:srgbClr val="000000">
+                  <a:alpha val="5250"/>
+                </a:srgbClr>
+              </a:outerShdw>
+            </a:effectLst>
+          </p:spPr>
+          <p:txBody>
+            <a:bodyPr wrap="none" lIns="0" tIns="0" rIns="0" bIns="0" anchor="t" anchorCtr="0">
+              <a:spAutoFit/>
+            </a:bodyPr>
+            <a:lstStyle/>
+            <a:p>
+              <a:pPr algn="ctr"/>
+              <a:r>
+                <a:rPr lang="zh-CN" sz="825" b="1" dirty="0">
+                  <a:solidFill>
+                    <a:srgbClr val="FFFFFF"/>
+                  </a:solidFill>
+                  <a:latin typeface="Arial"/>
+                  <a:ea typeface="Microsoft YaHei"/>
+                  <a:cs typeface="Arial"/>
+                </a:rPr>
+                <a:t>Tier A</a:t>
+              </a:r>
+            </a:p>
+          </p:txBody>
+        </p:sp>
+        <p:sp>
+          <p:nvSpPr>
+            <p:cNvPr id="27" name="Ellipse 27"/>
+            <p:cNvSpPr/>
+            <p:nvPr/>
+          </p:nvSpPr>
+          <p:spPr>
+            <a:xfrm>
+              <a:off x="476250" y="2705100"/>
+              <a:ext cx="419100" cy="419100"/>
+            </a:xfrm>
+            <a:prstGeom prst="ellipse">
+              <a:avLst/>
+            </a:prstGeom>
+            <a:solidFill>
+              <a:srgbClr val="F9E5E7"/>
+            </a:solidFill>
+            <a:ln>
+              <a:noFill/>
+            </a:ln>
+            <a:effectLst>
+              <a:outerShdw blurRad="76200" dist="19050" dir="5400000" algn="ctr" rotWithShape="0">
+                <a:srgbClr val="000000">
+                  <a:alpha val="5250"/>
+                </a:srgbClr>
+              </a:outerShdw>
+            </a:effectLst>
+          </p:spPr>
+        </p:sp>
+        <p:sp>
+          <p:nvSpPr>
+            <p:cNvPr id="28" name="Freeform 28"/>
+            <p:cNvSpPr/>
+            <p:nvPr/>
+          </p:nvSpPr>
+          <p:spPr>
+            <a:xfrm>
+              <a:off x="586618" y="2826720"/>
+              <a:ext cx="198107" cy="174587"/>
+            </a:xfrm>
+            <a:custGeom>
+              <a:avLst/>
+              <a:gdLst/>
+              <a:ahLst/>
+              <a:cxnLst/>
+              <a:rect l="l" t="t" r="r" b="b"/>
+              <a:pathLst>
+                <a:path w="198107" h="174587">
+                  <a:moveTo>
+                    <a:pt x="51357" y="2909"/>
+                  </a:moveTo>
+                  <a:cubicBezTo>
+                    <a:pt x="68432" y="0"/>
+                    <a:pt x="85906" y="4992"/>
+                    <a:pt x="98867" y="16483"/>
+                  </a:cubicBezTo>
+                  <a:lnTo>
+                    <a:pt x="99220" y="16797"/>
+                  </a:lnTo>
+                  <a:lnTo>
+                    <a:pt x="99544" y="16511"/>
+                  </a:lnTo>
+                  <a:cubicBezTo>
+                    <a:pt x="111899" y="5668"/>
+                    <a:pt x="128325" y="671"/>
+                    <a:pt x="144625" y="2795"/>
+                  </a:cubicBezTo>
+                  <a:lnTo>
+                    <a:pt x="146969" y="3138"/>
+                  </a:lnTo>
+                  <a:cubicBezTo>
+                    <a:pt x="167660" y="6711"/>
+                    <a:pt x="184726" y="21342"/>
+                    <a:pt x="191416" y="41246"/>
+                  </a:cubicBezTo>
+                  <a:cubicBezTo>
+                    <a:pt x="198107" y="61149"/>
+                    <a:pt x="193343" y="83119"/>
+                    <a:pt x="179011" y="98464"/>
+                  </a:cubicBezTo>
+                  <a:lnTo>
+                    <a:pt x="177296" y="100226"/>
+                  </a:lnTo>
+                  <a:lnTo>
+                    <a:pt x="176839" y="100617"/>
+                  </a:lnTo>
+                  <a:lnTo>
+                    <a:pt x="105878" y="170902"/>
+                  </a:lnTo>
+                  <a:cubicBezTo>
+                    <a:pt x="102491" y="174254"/>
+                    <a:pt x="97149" y="174587"/>
+                    <a:pt x="93371" y="171683"/>
+                  </a:cubicBezTo>
+                  <a:lnTo>
+                    <a:pt x="92476" y="170902"/>
+                  </a:lnTo>
+                  <a:lnTo>
+                    <a:pt x="21105" y="100207"/>
+                  </a:lnTo>
+                  <a:cubicBezTo>
+                    <a:pt x="5688" y="85207"/>
+                    <a:pt x="0" y="62820"/>
+                    <a:pt x="6386" y="42279"/>
+                  </a:cubicBezTo>
+                  <a:cubicBezTo>
+                    <a:pt x="12773" y="21739"/>
+                    <a:pt x="30152" y="6524"/>
+                    <a:pt x="51357" y="2909"/>
+                  </a:cubicBezTo>
+                  <a:close/>
+                </a:path>
+              </a:pathLst>
+            </a:custGeom>
+            <a:solidFill>
+              <a:srgbClr val="AE232F"/>
+            </a:solidFill>
+            <a:ln>
+              <a:noFill/>
+            </a:ln>
+            <a:effectLst>
+              <a:outerShdw blurRad="76200" dist="19050" dir="5400000" algn="ctr" rotWithShape="0">
+                <a:srgbClr val="000000">
+                  <a:alpha val="5250"/>
+                </a:srgbClr>
+              </a:outerShdw>
+            </a:effectLst>
+          </p:spPr>
+        </p:sp>
+        <p:sp>
+          <p:nvSpPr>
+            <p:cNvPr id="29" name="TextBox 29"/>
+            <p:cNvSpPr txBox="1"/>
+            <p:nvPr/>
+          </p:nvSpPr>
+          <p:spPr>
+            <a:xfrm>
+              <a:off x="995362" y="2736056"/>
+              <a:ext cx="950065" cy="228600"/>
+            </a:xfrm>
+            <a:prstGeom prst="rect">
+              <a:avLst/>
+            </a:prstGeom>
+            <a:noFill/>
+            <a:ln>
+              <a:noFill/>
+            </a:ln>
+            <a:effectLst>
+              <a:outerShdw blurRad="76200" dist="19050" dir="5400000" algn="ctr" rotWithShape="0">
+                <a:srgbClr val="000000">
+                  <a:alpha val="5250"/>
+                </a:srgbClr>
+              </a:outerShdw>
+            </a:effectLst>
+          </p:spPr>
+          <p:txBody>
+            <a:bodyPr wrap="none" lIns="0" tIns="0" rIns="0" bIns="0" anchor="t" anchorCtr="0">
+              <a:spAutoFit/>
+            </a:bodyPr>
+            <a:lstStyle/>
+            <a:p>
+              <a:pPr algn="l"/>
+              <a:r>
+                <a:rPr lang="zh-CN" sz="1125" b="1" dirty="0">
+                  <a:solidFill>
+                    <a:srgbClr val="1A1A1A"/>
+                  </a:solidFill>
+                  <a:latin typeface="Arial"/>
+                  <a:ea typeface="Microsoft YaHei"/>
+                  <a:cs typeface="Arial"/>
+                </a:rPr>
+                <a:t>Cardiologist</a:t>
+              </a:r>
+            </a:p>
+          </p:txBody>
+        </p:sp>
+        <p:sp>
+          <p:nvSpPr>
+            <p:cNvPr id="30" name="TextBox 30"/>
+            <p:cNvSpPr txBox="1"/>
+            <p:nvPr/>
+          </p:nvSpPr>
+          <p:spPr>
+            <a:xfrm>
+              <a:off x="999172" y="2939891"/>
+              <a:ext cx="4497139" cy="167640"/>
+            </a:xfrm>
+            <a:prstGeom prst="rect">
+              <a:avLst/>
+            </a:prstGeom>
+            <a:noFill/>
+            <a:ln>
+              <a:noFill/>
+            </a:ln>
+            <a:effectLst>
+              <a:outerShdw blurRad="76200" dist="19050" dir="5400000" algn="ctr" rotWithShape="0">
+                <a:srgbClr val="000000">
+                  <a:alpha val="5250"/>
+                </a:srgbClr>
+              </a:outerShdw>
+            </a:effectLst>
+          </p:spPr>
+          <p:txBody>
+            <a:bodyPr wrap="none" lIns="0" tIns="0" rIns="0" bIns="0" anchor="t" anchorCtr="0">
+              <a:spAutoFit/>
+            </a:bodyPr>
+            <a:lstStyle/>
+            <a:p>
+              <a:pPr algn="l"/>
+              <a:r>
+                <a:rPr lang="zh-CN" sz="825" b="1" dirty="0">
+                  <a:solidFill>
+                    <a:srgbClr val="AE232F"/>
+                  </a:solidFill>
+                  <a:latin typeface="Arial"/>
+                  <a:ea typeface="Microsoft YaHei"/>
+                  <a:cs typeface="Arial"/>
+                </a:rPr>
+                <a:t>Clexane role: ACS management (UA / NSTEMI) + post-PCI bridging anticoagulation</a:t>
+              </a:r>
+            </a:p>
+          </p:txBody>
+        </p:sp>
+        <p:sp>
+          <p:nvSpPr>
+            <p:cNvPr id="31" name="Line 31"/>
+            <p:cNvSpPr/>
+            <p:nvPr/>
+          </p:nvSpPr>
+          <p:spPr>
+            <a:xfrm>
+              <a:off x="476250" y="3152775"/>
+              <a:ext cx="5448300" cy="9525"/>
+            </a:xfrm>
+            <a:custGeom>
+              <a:avLst/>
+              <a:gdLst/>
+              <a:ahLst/>
+              <a:cxnLst/>
+              <a:rect l="l" t="t" r="r" b="b"/>
+              <a:pathLst>
+                <a:path w="5448300" h="9525">
+                  <a:moveTo>
+                    <a:pt x="0" y="0"/>
+                  </a:moveTo>
+                  <a:lnTo>
+                    <a:pt x="5448300" y="0"/>
+                  </a:lnTo>
+                </a:path>
+              </a:pathLst>
+            </a:custGeom>
+            <a:noFill/>
+            <a:ln w="9525">
+              <a:solidFill>
+                <a:srgbClr val="F5F5F5"/>
+              </a:solidFill>
+            </a:ln>
+          </p:spPr>
+        </p:sp>
+        <p:sp>
+          <p:nvSpPr>
+            <p:cNvPr id="32" name="TextBox 32"/>
+            <p:cNvSpPr txBox="1"/>
+            <p:nvPr/>
+          </p:nvSpPr>
+          <p:spPr>
+            <a:xfrm>
+              <a:off x="464820" y="3217545"/>
+              <a:ext cx="848263" cy="182880"/>
+            </a:xfrm>
+            <a:prstGeom prst="rect">
+              <a:avLst/>
+            </a:prstGeom>
+            <a:noFill/>
+            <a:ln>
+              <a:noFill/>
+            </a:ln>
+            <a:effectLst>
+              <a:outerShdw blurRad="76200" dist="19050" dir="5400000" algn="ctr" rotWithShape="0">
+                <a:srgbClr val="000000">
+                  <a:alpha val="5250"/>
+                </a:srgbClr>
+              </a:outerShdw>
+            </a:effectLst>
+          </p:spPr>
+          <p:txBody>
+            <a:bodyPr wrap="none" lIns="0" tIns="0" rIns="0" bIns="0" anchor="t" anchorCtr="0">
+              <a:spAutoFit/>
+            </a:bodyPr>
+            <a:lstStyle/>
+            <a:p>
+              <a:pPr algn="l"/>
+              <a:r>
+                <a:rPr lang="zh-CN" sz="900" b="1" dirty="0">
+                  <a:solidFill>
+                    <a:srgbClr val="555555"/>
+                  </a:solidFill>
+                  <a:latin typeface="Arial"/>
+                  <a:ea typeface="Microsoft YaHei"/>
+                  <a:cs typeface="Arial"/>
+                </a:rPr>
+                <a:t>Key message:</a:t>
+              </a:r>
+            </a:p>
+          </p:txBody>
+        </p:sp>
+        <p:sp>
+          <p:nvSpPr>
+            <p:cNvPr id="33" name="TextBox 33"/>
+            <p:cNvSpPr txBox="1"/>
+            <p:nvPr/>
+          </p:nvSpPr>
+          <p:spPr>
+            <a:xfrm>
+              <a:off x="464820" y="3388995"/>
+              <a:ext cx="4457414" cy="182880"/>
+            </a:xfrm>
+            <a:prstGeom prst="rect">
+              <a:avLst/>
+            </a:prstGeom>
+            <a:noFill/>
+            <a:ln>
+              <a:noFill/>
+            </a:ln>
+            <a:effectLst>
+              <a:outerShdw blurRad="76200" dist="19050" dir="5400000" algn="ctr" rotWithShape="0">
+                <a:srgbClr val="000000">
+                  <a:alpha val="5250"/>
+                </a:srgbClr>
+              </a:outerShdw>
+            </a:effectLst>
+          </p:spPr>
+          <p:txBody>
+            <a:bodyPr wrap="none" lIns="0" tIns="0" rIns="0" bIns="0" anchor="t" anchorCtr="0">
+              <a:spAutoFit/>
+            </a:bodyPr>
+            <a:lstStyle/>
+            <a:p>
+              <a:pPr algn="l"/>
+              <a:r>
+                <a:rPr lang="zh-CN" sz="900" dirty="0">
+                  <a:solidFill>
+                    <a:srgbClr val="555555"/>
+                  </a:solidFill>
+                  <a:latin typeface="Arial"/>
+                  <a:ea typeface="Microsoft YaHei"/>
+                  <a:cs typeface="Arial"/>
+                </a:rPr>
+                <a:t>ESSENCE &amp; TIMI 11B trial evidence — Clexane superior to UFH in ACS outcomes.</a:t>
+              </a:r>
+            </a:p>
+          </p:txBody>
+        </p:sp>
+        <p:sp>
+          <p:nvSpPr>
+            <p:cNvPr id="34" name="TextBox 34"/>
+            <p:cNvSpPr txBox="1"/>
+            <p:nvPr/>
+          </p:nvSpPr>
+          <p:spPr>
+            <a:xfrm>
+              <a:off x="464820" y="3560445"/>
+              <a:ext cx="4757452" cy="182880"/>
+            </a:xfrm>
+            <a:prstGeom prst="rect">
+              <a:avLst/>
+            </a:prstGeom>
+            <a:noFill/>
+            <a:ln>
+              <a:noFill/>
+            </a:ln>
+            <a:effectLst>
+              <a:outerShdw blurRad="76200" dist="19050" dir="5400000" algn="ctr" rotWithShape="0">
+                <a:srgbClr val="000000">
+                  <a:alpha val="5250"/>
+                </a:srgbClr>
+              </a:outerShdw>
+            </a:effectLst>
+          </p:spPr>
+          <p:txBody>
+            <a:bodyPr wrap="none" lIns="0" tIns="0" rIns="0" bIns="0" anchor="t" anchorCtr="0">
+              <a:spAutoFit/>
+            </a:bodyPr>
+            <a:lstStyle/>
+            <a:p>
+              <a:pPr algn="l"/>
+              <a:r>
+                <a:rPr lang="zh-CN" sz="900" dirty="0">
+                  <a:solidFill>
+                    <a:srgbClr val="555555"/>
+                  </a:solidFill>
+                  <a:latin typeface="Arial"/>
+                  <a:ea typeface="Microsoft YaHei"/>
+                  <a:cs typeface="Arial"/>
+                </a:rPr>
+                <a:t>Reduces recurrent ischemia by ~20%. No drip, no aPTT — simplified CCU workflow.</a:t>
+              </a:r>
+            </a:p>
+          </p:txBody>
+        </p:sp>
+        <p:sp>
+          <p:nvSpPr>
+            <p:cNvPr id="35" name="TextBox 35"/>
+            <p:cNvSpPr txBox="1"/>
+            <p:nvPr/>
+          </p:nvSpPr>
+          <p:spPr>
+            <a:xfrm>
+              <a:off x="464820" y="3731895"/>
+              <a:ext cx="4565428" cy="182880"/>
+            </a:xfrm>
+            <a:prstGeom prst="rect">
+              <a:avLst/>
+            </a:prstGeom>
+            <a:noFill/>
+            <a:ln>
+              <a:noFill/>
+            </a:ln>
+            <a:effectLst>
+              <a:outerShdw blurRad="76200" dist="19050" dir="5400000" algn="ctr" rotWithShape="0">
+                <a:srgbClr val="000000">
+                  <a:alpha val="5250"/>
+                </a:srgbClr>
+              </a:outerShdw>
+            </a:effectLst>
+          </p:spPr>
+          <p:txBody>
+            <a:bodyPr wrap="none" lIns="0" tIns="0" rIns="0" bIns="0" anchor="t" anchorCtr="0">
+              <a:spAutoFit/>
+            </a:bodyPr>
+            <a:lstStyle/>
+            <a:p>
+              <a:pPr algn="l"/>
+              <a:r>
+                <a:rPr lang="zh-CN" sz="900" dirty="0">
+                  <a:solidFill>
+                    <a:srgbClr val="555555"/>
+                  </a:solidFill>
+                  <a:latin typeface="Arial"/>
+                  <a:ea typeface="Microsoft YaHei"/>
+                  <a:cs typeface="Arial"/>
+                </a:rPr>
+                <a:t>Post-PCI: overlap bridging until oral anticoagulants reach therapeutic range.</a:t>
+              </a:r>
+            </a:p>
+          </p:txBody>
+        </p:sp>
+        <p:sp>
+          <p:nvSpPr>
+            <p:cNvPr id="36" name="TextBox 36"/>
+            <p:cNvSpPr txBox="1"/>
+            <p:nvPr/>
+          </p:nvSpPr>
+          <p:spPr>
+            <a:xfrm>
+              <a:off x="464820" y="3903345"/>
+              <a:ext cx="4343400" cy="182880"/>
+            </a:xfrm>
+            <a:prstGeom prst="rect">
+              <a:avLst/>
+            </a:prstGeom>
+            <a:noFill/>
+            <a:ln>
+              <a:noFill/>
+            </a:ln>
+            <a:effectLst>
+              <a:outerShdw blurRad="76200" dist="19050" dir="5400000" algn="ctr" rotWithShape="0">
+                <a:srgbClr val="000000">
+                  <a:alpha val="5250"/>
+                </a:srgbClr>
+              </a:outerShdw>
+            </a:effectLst>
+          </p:spPr>
+          <p:txBody>
+            <a:bodyPr wrap="none" lIns="0" tIns="0" rIns="0" bIns="0" anchor="t" anchorCtr="0">
+              <a:spAutoFit/>
+            </a:bodyPr>
+            <a:lstStyle/>
+            <a:p>
+              <a:pPr algn="l"/>
+              <a:r>
+                <a:rPr lang="zh-CN" sz="900" dirty="0">
+                  <a:solidFill>
+                    <a:srgbClr val="555555"/>
+                  </a:solidFill>
+                  <a:latin typeface="Arial"/>
+                  <a:ea typeface="Microsoft YaHei"/>
+                  <a:cs typeface="Arial"/>
+                </a:rPr>
+                <a:t>ACC/AHA Class I recommendation for enoxaparin in UA/NSTEMI management.</a:t>
+              </a:r>
+            </a:p>
+          </p:txBody>
+        </p:sp>
+      </p:grpSp>
+      <p:grpSp>
+        <p:nvGrpSpPr>
+          <p:cNvPr id="53" name="Group 53"/>
+          <p:cNvGrpSpPr/>
+          <p:nvPr/>
+        </p:nvGrpSpPr>
+        <p:grpSpPr>
+          <a:xfrm>
+            <a:off x="342900" y="4305300"/>
+            <a:ext cx="5695950" cy="1600200"/>
+            <a:chOff x="342900" y="4305300"/>
+            <a:chExt cx="5695950" cy="1600200"/>
+          </a:xfrm>
+          <a:effectLst>
+            <a:outerShdw blurRad="76200" dist="19050" dir="5400000" algn="ctr" rotWithShape="0">
+              <a:srgbClr val="000000">
+                <a:alpha val="5250"/>
+              </a:srgbClr>
+            </a:outerShdw>
+          </a:effectLst>
+        </p:grpSpPr>
+        <p:sp>
+          <p:nvSpPr>
+            <p:cNvPr id="38" name="Rectangle 38"/>
+            <p:cNvSpPr/>
+            <p:nvPr/>
+          </p:nvSpPr>
+          <p:spPr>
+            <a:xfrm>
+              <a:off x="342900" y="4305300"/>
+              <a:ext cx="5695950" cy="1600200"/>
+            </a:xfrm>
+            <a:prstGeom prst="roundRect">
+              <a:avLst>
+                <a:gd name="adj" fmla="val 4762"/>
+              </a:avLst>
+            </a:prstGeom>
+            <a:solidFill>
+              <a:srgbClr val="FFFFFF"/>
+            </a:solidFill>
+            <a:ln w="14288">
+              <a:solidFill>
+                <a:srgbClr val="AE232F"/>
+              </a:solidFill>
+            </a:ln>
+            <a:effectLst>
+              <a:outerShdw blurRad="76200" dist="19050" dir="5400000" algn="ctr" rotWithShape="0">
+                <a:srgbClr val="000000">
+                  <a:alpha val="5250"/>
+                </a:srgbClr>
+              </a:outerShdw>
+            </a:effectLst>
+          </p:spPr>
+        </p:sp>
+        <p:sp>
+          <p:nvSpPr>
+            <p:cNvPr id="39" name="Rectangle 39"/>
+            <p:cNvSpPr/>
+            <p:nvPr/>
+          </p:nvSpPr>
+          <p:spPr>
+            <a:xfrm>
+              <a:off x="342900" y="4305300"/>
+              <a:ext cx="47625" cy="1600200"/>
+            </a:xfrm>
+            <a:prstGeom prst="roundRect">
+              <a:avLst>
+                <a:gd name="adj" fmla="val 50000"/>
+              </a:avLst>
+            </a:prstGeom>
+            <a:solidFill>
+              <a:srgbClr val="AE232F"/>
+            </a:solidFill>
+            <a:ln>
+              <a:noFill/>
+            </a:ln>
+            <a:effectLst>
+              <a:outerShdw blurRad="76200" dist="19050" dir="5400000" algn="ctr" rotWithShape="0">
+                <a:srgbClr val="000000">
+                  <a:alpha val="5250"/>
+                </a:srgbClr>
+              </a:outerShdw>
+            </a:effectLst>
+          </p:spPr>
+        </p:sp>
+        <p:sp>
+          <p:nvSpPr>
+            <p:cNvPr id="40" name="Rectangle 40"/>
+            <p:cNvSpPr/>
+            <p:nvPr/>
+          </p:nvSpPr>
+          <p:spPr>
+            <a:xfrm>
+              <a:off x="5467350" y="4381500"/>
+              <a:ext cx="457200" cy="209550"/>
+            </a:xfrm>
+            <a:prstGeom prst="roundRect">
+              <a:avLst>
+                <a:gd name="adj" fmla="val 18182"/>
+              </a:avLst>
+            </a:prstGeom>
+            <a:solidFill>
+              <a:srgbClr val="AE232F"/>
+            </a:solidFill>
+            <a:ln>
+              <a:noFill/>
+            </a:ln>
+            <a:effectLst>
+              <a:outerShdw blurRad="76200" dist="19050" dir="5400000" algn="ctr" rotWithShape="0">
+                <a:srgbClr val="000000">
+                  <a:alpha val="5250"/>
+                </a:srgbClr>
+              </a:outerShdw>
+            </a:effectLst>
+          </p:spPr>
+        </p:sp>
+        <p:sp>
+          <p:nvSpPr>
+            <p:cNvPr id="41" name="TextBox 41"/>
+            <p:cNvSpPr txBox="1"/>
+            <p:nvPr/>
+          </p:nvSpPr>
+          <p:spPr>
+            <a:xfrm>
+              <a:off x="5523752" y="4435316"/>
+              <a:ext cx="344395" cy="167640"/>
+            </a:xfrm>
+            <a:prstGeom prst="rect">
+              <a:avLst/>
+            </a:prstGeom>
+            <a:noFill/>
+            <a:ln>
+              <a:noFill/>
+            </a:ln>
+            <a:effectLst>
+              <a:outerShdw blurRad="76200" dist="19050" dir="5400000" algn="ctr" rotWithShape="0">
+                <a:srgbClr val="000000">
+                  <a:alpha val="5250"/>
+                </a:srgbClr>
+              </a:outerShdw>
+            </a:effectLst>
+          </p:spPr>
+          <p:txBody>
+            <a:bodyPr wrap="none" lIns="0" tIns="0" rIns="0" bIns="0" anchor="t" anchorCtr="0">
+              <a:spAutoFit/>
+            </a:bodyPr>
+            <a:lstStyle/>
+            <a:p>
+              <a:pPr algn="ctr"/>
+              <a:r>
+                <a:rPr lang="zh-CN" sz="825" b="1" dirty="0">
+                  <a:solidFill>
+                    <a:srgbClr val="FFFFFF"/>
+                  </a:solidFill>
+                  <a:latin typeface="Arial"/>
+                  <a:ea typeface="Microsoft YaHei"/>
+                  <a:cs typeface="Arial"/>
+                </a:rPr>
+                <a:t>Tier A</a:t>
+              </a:r>
+            </a:p>
+          </p:txBody>
+        </p:sp>
+        <p:sp>
+          <p:nvSpPr>
+            <p:cNvPr id="42" name="Rectangle 42"/>
+            <p:cNvSpPr/>
+            <p:nvPr/>
+          </p:nvSpPr>
+          <p:spPr>
+            <a:xfrm>
+              <a:off x="342900" y="4305300"/>
+              <a:ext cx="5695950" cy="1600200"/>
+            </a:xfrm>
+            <a:prstGeom prst="roundRect">
+              <a:avLst>
+                <a:gd name="adj" fmla="val 4762"/>
+              </a:avLst>
+            </a:prstGeom>
+            <a:solidFill>
+              <a:srgbClr val="F9E5E7">
+                <a:alpha val="15000"/>
+              </a:srgbClr>
+            </a:solidFill>
+            <a:ln>
+              <a:noFill/>
+            </a:ln>
+            <a:effectLst>
+              <a:outerShdw blurRad="76200" dist="19050" dir="5400000" algn="ctr" rotWithShape="0">
+                <a:srgbClr val="000000">
+                  <a:alpha val="5250"/>
+                </a:srgbClr>
+              </a:outerShdw>
+            </a:effectLst>
+          </p:spPr>
+        </p:sp>
+        <p:sp>
+          <p:nvSpPr>
+            <p:cNvPr id="43" name="Ellipse 43"/>
+            <p:cNvSpPr/>
+            <p:nvPr/>
+          </p:nvSpPr>
+          <p:spPr>
+            <a:xfrm>
+              <a:off x="476250" y="4419600"/>
+              <a:ext cx="419100" cy="419100"/>
+            </a:xfrm>
+            <a:prstGeom prst="ellipse">
+              <a:avLst/>
+            </a:prstGeom>
+            <a:solidFill>
+              <a:srgbClr val="F9E5E7"/>
+            </a:solidFill>
+            <a:ln>
+              <a:noFill/>
+            </a:ln>
+            <a:effectLst>
+              <a:outerShdw blurRad="76200" dist="19050" dir="5400000" algn="ctr" rotWithShape="0">
+                <a:srgbClr val="000000">
+                  <a:alpha val="5250"/>
+                </a:srgbClr>
+              </a:outerShdw>
+            </a:effectLst>
+          </p:spPr>
+        </p:sp>
+        <p:sp>
+          <p:nvSpPr>
+            <p:cNvPr id="44" name="Freeform 44"/>
+            <p:cNvSpPr/>
+            <p:nvPr/>
+          </p:nvSpPr>
+          <p:spPr>
+            <a:xfrm>
+              <a:off x="609598" y="4533900"/>
+              <a:ext cx="152404" cy="190500"/>
+            </a:xfrm>
+            <a:custGeom>
+              <a:avLst/>
+              <a:gdLst/>
+              <a:ahLst/>
+              <a:cxnLst/>
+              <a:rect l="l" t="t" r="r" b="b"/>
+              <a:pathLst>
+                <a:path w="152404" h="190500">
+                  <a:moveTo>
+                    <a:pt x="133324" y="20669"/>
+                  </a:moveTo>
+                  <a:cubicBezTo>
+                    <a:pt x="144757" y="24698"/>
+                    <a:pt x="152404" y="35502"/>
+                    <a:pt x="152402" y="47625"/>
+                  </a:cubicBezTo>
+                  <a:lnTo>
+                    <a:pt x="152402" y="161925"/>
+                  </a:lnTo>
+                  <a:cubicBezTo>
+                    <a:pt x="152402" y="177707"/>
+                    <a:pt x="139609" y="190500"/>
+                    <a:pt x="123827" y="190500"/>
+                  </a:cubicBezTo>
+                  <a:lnTo>
+                    <a:pt x="28577" y="190500"/>
+                  </a:lnTo>
+                  <a:cubicBezTo>
+                    <a:pt x="12796" y="190500"/>
+                    <a:pt x="2" y="177707"/>
+                    <a:pt x="2" y="161925"/>
+                  </a:cubicBezTo>
+                  <a:lnTo>
+                    <a:pt x="2" y="47625"/>
+                  </a:lnTo>
+                  <a:cubicBezTo>
+                    <a:pt x="0" y="35502"/>
+                    <a:pt x="7647" y="24698"/>
+                    <a:pt x="19081" y="20669"/>
+                  </a:cubicBezTo>
+                  <a:cubicBezTo>
+                    <a:pt x="19948" y="41065"/>
+                    <a:pt x="36738" y="57153"/>
+                    <a:pt x="57152" y="57150"/>
+                  </a:cubicBezTo>
+                  <a:lnTo>
+                    <a:pt x="95252" y="57150"/>
+                  </a:lnTo>
+                  <a:cubicBezTo>
+                    <a:pt x="114809" y="57152"/>
+                    <a:pt x="131191" y="42346"/>
+                    <a:pt x="133162" y="22889"/>
+                  </a:cubicBezTo>
+                  <a:close/>
+                  <a:moveTo>
+                    <a:pt x="98043" y="88516"/>
+                  </a:moveTo>
+                  <a:lnTo>
+                    <a:pt x="66677" y="119872"/>
+                  </a:lnTo>
+                  <a:lnTo>
+                    <a:pt x="54361" y="107566"/>
+                  </a:lnTo>
+                  <a:cubicBezTo>
+                    <a:pt x="51970" y="105090"/>
+                    <a:pt x="48428" y="104097"/>
+                    <a:pt x="45098" y="104968"/>
+                  </a:cubicBezTo>
+                  <a:cubicBezTo>
+                    <a:pt x="41768" y="105840"/>
+                    <a:pt x="39167" y="108441"/>
+                    <a:pt x="38295" y="111771"/>
+                  </a:cubicBezTo>
+                  <a:cubicBezTo>
+                    <a:pt x="37424" y="115101"/>
+                    <a:pt x="38417" y="118643"/>
+                    <a:pt x="40893" y="121034"/>
+                  </a:cubicBezTo>
+                  <a:lnTo>
+                    <a:pt x="59943" y="140084"/>
+                  </a:lnTo>
+                  <a:cubicBezTo>
+                    <a:pt x="63662" y="143803"/>
+                    <a:pt x="69692" y="143803"/>
+                    <a:pt x="73411" y="140084"/>
+                  </a:cubicBezTo>
+                  <a:lnTo>
+                    <a:pt x="111511" y="101984"/>
+                  </a:lnTo>
+                  <a:cubicBezTo>
+                    <a:pt x="115121" y="98247"/>
+                    <a:pt x="115069" y="92306"/>
+                    <a:pt x="111395" y="88632"/>
+                  </a:cubicBezTo>
+                  <a:cubicBezTo>
+                    <a:pt x="107721" y="84958"/>
+                    <a:pt x="101780" y="84906"/>
+                    <a:pt x="98043" y="88516"/>
+                  </a:cubicBezTo>
+                  <a:moveTo>
+                    <a:pt x="95252" y="0"/>
+                  </a:moveTo>
+                  <a:cubicBezTo>
+                    <a:pt x="105773" y="0"/>
+                    <a:pt x="114302" y="8529"/>
+                    <a:pt x="114302" y="19050"/>
+                  </a:cubicBezTo>
+                  <a:cubicBezTo>
+                    <a:pt x="114302" y="29571"/>
+                    <a:pt x="105773" y="38100"/>
+                    <a:pt x="95252" y="38100"/>
+                  </a:cubicBezTo>
+                  <a:lnTo>
+                    <a:pt x="57152" y="38100"/>
+                  </a:lnTo>
+                  <a:cubicBezTo>
+                    <a:pt x="46631" y="38100"/>
+                    <a:pt x="38102" y="29571"/>
+                    <a:pt x="38102" y="19050"/>
+                  </a:cubicBezTo>
+                  <a:cubicBezTo>
+                    <a:pt x="38102" y="8529"/>
+                    <a:pt x="46631" y="0"/>
+                    <a:pt x="57152" y="0"/>
+                  </a:cubicBezTo>
+                  <a:close/>
+                </a:path>
+              </a:pathLst>
+            </a:custGeom>
+            <a:solidFill>
+              <a:srgbClr val="AE232F"/>
+            </a:solidFill>
+            <a:ln>
+              <a:noFill/>
+            </a:ln>
+            <a:effectLst>
+              <a:outerShdw blurRad="76200" dist="19050" dir="5400000" algn="ctr" rotWithShape="0">
+                <a:srgbClr val="000000">
+                  <a:alpha val="5250"/>
+                </a:srgbClr>
+              </a:outerShdw>
+            </a:effectLst>
+          </p:spPr>
+        </p:sp>
+        <p:sp>
+          <p:nvSpPr>
+            <p:cNvPr id="45" name="TextBox 45"/>
+            <p:cNvSpPr txBox="1"/>
+            <p:nvPr/>
+          </p:nvSpPr>
+          <p:spPr>
+            <a:xfrm>
+              <a:off x="995362" y="4450556"/>
+              <a:ext cx="1312360" cy="228600"/>
+            </a:xfrm>
+            <a:prstGeom prst="rect">
+              <a:avLst/>
+            </a:prstGeom>
+            <a:noFill/>
+            <a:ln>
+              <a:noFill/>
+            </a:ln>
+            <a:effectLst>
+              <a:outerShdw blurRad="76200" dist="19050" dir="5400000" algn="ctr" rotWithShape="0">
+                <a:srgbClr val="000000">
+                  <a:alpha val="5250"/>
+                </a:srgbClr>
+              </a:outerShdw>
+            </a:effectLst>
+          </p:spPr>
+          <p:txBody>
+            <a:bodyPr wrap="none" lIns="0" tIns="0" rIns="0" bIns="0" anchor="t" anchorCtr="0">
+              <a:spAutoFit/>
+            </a:bodyPr>
+            <a:lstStyle/>
+            <a:p>
+              <a:pPr algn="l"/>
+              <a:r>
+                <a:rPr lang="zh-CN" sz="1125" b="1" dirty="0">
+                  <a:solidFill>
+                    <a:srgbClr val="1A1A1A"/>
+                  </a:solidFill>
+                  <a:latin typeface="Arial"/>
+                  <a:ea typeface="Microsoft YaHei"/>
+                  <a:cs typeface="Arial"/>
+                </a:rPr>
+                <a:t>Ward Pharmacist</a:t>
+              </a:r>
+            </a:p>
+          </p:txBody>
+        </p:sp>
+        <p:sp>
+          <p:nvSpPr>
+            <p:cNvPr id="46" name="TextBox 46"/>
+            <p:cNvSpPr txBox="1"/>
+            <p:nvPr/>
+          </p:nvSpPr>
+          <p:spPr>
+            <a:xfrm>
+              <a:off x="999172" y="4654391"/>
+              <a:ext cx="4572224" cy="167640"/>
+            </a:xfrm>
+            <a:prstGeom prst="rect">
+              <a:avLst/>
+            </a:prstGeom>
+            <a:noFill/>
+            <a:ln>
+              <a:noFill/>
+            </a:ln>
+            <a:effectLst>
+              <a:outerShdw blurRad="76200" dist="19050" dir="5400000" algn="ctr" rotWithShape="0">
+                <a:srgbClr val="000000">
+                  <a:alpha val="5250"/>
+                </a:srgbClr>
+              </a:outerShdw>
+            </a:effectLst>
+          </p:spPr>
+          <p:txBody>
+            <a:bodyPr wrap="none" lIns="0" tIns="0" rIns="0" bIns="0" anchor="t" anchorCtr="0">
+              <a:spAutoFit/>
+            </a:bodyPr>
+            <a:lstStyle/>
+            <a:p>
+              <a:pPr algn="l"/>
+              <a:r>
+                <a:rPr lang="zh-CN" sz="825" b="1" dirty="0">
+                  <a:solidFill>
+                    <a:srgbClr val="AE232F"/>
+                  </a:solidFill>
+                  <a:latin typeface="Arial"/>
+                  <a:ea typeface="Microsoft YaHei"/>
+                  <a:cs typeface="Arial"/>
+                </a:rPr>
+                <a:t>Clexane role: Formulary inclusion &amp; protocol design for anticoagulation pathways</a:t>
+              </a:r>
+            </a:p>
+          </p:txBody>
+        </p:sp>
+        <p:sp>
+          <p:nvSpPr>
+            <p:cNvPr id="47" name="Line 47"/>
+            <p:cNvSpPr/>
+            <p:nvPr/>
+          </p:nvSpPr>
+          <p:spPr>
+            <a:xfrm>
+              <a:off x="476250" y="4867275"/>
+              <a:ext cx="5448300" cy="9525"/>
+            </a:xfrm>
+            <a:custGeom>
+              <a:avLst/>
+              <a:gdLst/>
+              <a:ahLst/>
+              <a:cxnLst/>
+              <a:rect l="l" t="t" r="r" b="b"/>
+              <a:pathLst>
+                <a:path w="5448300" h="9525">
+                  <a:moveTo>
+                    <a:pt x="0" y="0"/>
+                  </a:moveTo>
+                  <a:lnTo>
+                    <a:pt x="5448300" y="0"/>
+                  </a:lnTo>
+                </a:path>
+              </a:pathLst>
+            </a:custGeom>
+            <a:noFill/>
+            <a:ln w="9525">
+              <a:solidFill>
+                <a:srgbClr val="E0E0E0"/>
+              </a:solidFill>
+            </a:ln>
+          </p:spPr>
+        </p:sp>
+        <p:sp>
+          <p:nvSpPr>
+            <p:cNvPr id="48" name="TextBox 48"/>
+            <p:cNvSpPr txBox="1"/>
+            <p:nvPr/>
+          </p:nvSpPr>
+          <p:spPr>
+            <a:xfrm>
+              <a:off x="464820" y="4932045"/>
+              <a:ext cx="848263" cy="182880"/>
+            </a:xfrm>
+            <a:prstGeom prst="rect">
+              <a:avLst/>
+            </a:prstGeom>
+            <a:noFill/>
+            <a:ln>
+              <a:noFill/>
+            </a:ln>
+            <a:effectLst>
+              <a:outerShdw blurRad="76200" dist="19050" dir="5400000" algn="ctr" rotWithShape="0">
+                <a:srgbClr val="000000">
+                  <a:alpha val="5250"/>
+                </a:srgbClr>
+              </a:outerShdw>
+            </a:effectLst>
+          </p:spPr>
+          <p:txBody>
+            <a:bodyPr wrap="none" lIns="0" tIns="0" rIns="0" bIns="0" anchor="t" anchorCtr="0">
+              <a:spAutoFit/>
+            </a:bodyPr>
+            <a:lstStyle/>
+            <a:p>
+              <a:pPr algn="l"/>
+              <a:r>
+                <a:rPr lang="zh-CN" sz="900" b="1" dirty="0">
+                  <a:solidFill>
+                    <a:srgbClr val="555555"/>
+                  </a:solidFill>
+                  <a:latin typeface="Arial"/>
+                  <a:ea typeface="Microsoft YaHei"/>
+                  <a:cs typeface="Arial"/>
+                </a:rPr>
+                <a:t>Key message:</a:t>
+              </a:r>
+            </a:p>
+          </p:txBody>
+        </p:sp>
+        <p:sp>
+          <p:nvSpPr>
+            <p:cNvPr id="49" name="TextBox 49"/>
+            <p:cNvSpPr txBox="1"/>
+            <p:nvPr/>
+          </p:nvSpPr>
+          <p:spPr>
+            <a:xfrm>
+              <a:off x="464820" y="5103495"/>
+              <a:ext cx="4931474" cy="182880"/>
+            </a:xfrm>
+            <a:prstGeom prst="rect">
+              <a:avLst/>
+            </a:prstGeom>
+            <a:noFill/>
+            <a:ln>
+              <a:noFill/>
+            </a:ln>
+            <a:effectLst>
+              <a:outerShdw blurRad="76200" dist="19050" dir="5400000" algn="ctr" rotWithShape="0">
+                <a:srgbClr val="000000">
+                  <a:alpha val="5250"/>
+                </a:srgbClr>
+              </a:outerShdw>
+            </a:effectLst>
+          </p:spPr>
+          <p:txBody>
+            <a:bodyPr wrap="none" lIns="0" tIns="0" rIns="0" bIns="0" anchor="t" anchorCtr="0">
+              <a:spAutoFit/>
+            </a:bodyPr>
+            <a:lstStyle/>
+            <a:p>
+              <a:pPr algn="l"/>
+              <a:r>
+                <a:rPr lang="zh-CN" sz="900" dirty="0">
+                  <a:solidFill>
+                    <a:srgbClr val="555555"/>
+                  </a:solidFill>
+                  <a:latin typeface="Arial"/>
+                  <a:ea typeface="Microsoft YaHei"/>
+                  <a:cs typeface="Arial"/>
+                </a:rPr>
+                <a:t>Clinical evidence + cost-effectiveness data — PharmD partner, not just a call point.</a:t>
+              </a:r>
+            </a:p>
+          </p:txBody>
+        </p:sp>
+        <p:sp>
+          <p:nvSpPr>
+            <p:cNvPr id="50" name="TextBox 50"/>
+            <p:cNvSpPr txBox="1"/>
+            <p:nvPr/>
+          </p:nvSpPr>
+          <p:spPr>
+            <a:xfrm>
+              <a:off x="464820" y="5274945"/>
+              <a:ext cx="5297519" cy="182880"/>
+            </a:xfrm>
+            <a:prstGeom prst="rect">
+              <a:avLst/>
+            </a:prstGeom>
+            <a:noFill/>
+            <a:ln>
+              <a:noFill/>
+            </a:ln>
+            <a:effectLst>
+              <a:outerShdw blurRad="76200" dist="19050" dir="5400000" algn="ctr" rotWithShape="0">
+                <a:srgbClr val="000000">
+                  <a:alpha val="5250"/>
+                </a:srgbClr>
+              </a:outerShdw>
+            </a:effectLst>
+          </p:spPr>
+          <p:txBody>
+            <a:bodyPr wrap="none" lIns="0" tIns="0" rIns="0" bIns="0" anchor="t" anchorCtr="0">
+              <a:spAutoFit/>
+            </a:bodyPr>
+            <a:lstStyle/>
+            <a:p>
+              <a:pPr algn="l"/>
+              <a:r>
+                <a:rPr lang="zh-CN" sz="900" dirty="0">
+                  <a:solidFill>
+                    <a:srgbClr val="555555"/>
+                  </a:solidFill>
+                  <a:latin typeface="Arial"/>
+                  <a:ea typeface="Microsoft YaHei"/>
+                  <a:cs typeface="Arial"/>
+                </a:rPr>
+                <a:t>As a Pharm.D. myself, I speak their language: PK, dosing adjustment, interaction review.</a:t>
+              </a:r>
+            </a:p>
+          </p:txBody>
+        </p:sp>
+        <p:sp>
+          <p:nvSpPr>
+            <p:cNvPr id="51" name="TextBox 51"/>
+            <p:cNvSpPr txBox="1"/>
+            <p:nvPr/>
+          </p:nvSpPr>
+          <p:spPr>
+            <a:xfrm>
+              <a:off x="464820" y="5446395"/>
+              <a:ext cx="5261515" cy="182880"/>
+            </a:xfrm>
+            <a:prstGeom prst="rect">
+              <a:avLst/>
+            </a:prstGeom>
+            <a:noFill/>
+            <a:ln>
+              <a:noFill/>
+            </a:ln>
+            <a:effectLst>
+              <a:outerShdw blurRad="76200" dist="19050" dir="5400000" algn="ctr" rotWithShape="0">
+                <a:srgbClr val="000000">
+                  <a:alpha val="5250"/>
+                </a:srgbClr>
+              </a:outerShdw>
+            </a:effectLst>
+          </p:spPr>
+          <p:txBody>
+            <a:bodyPr wrap="none" lIns="0" tIns="0" rIns="0" bIns="0" anchor="t" anchorCtr="0">
+              <a:spAutoFit/>
+            </a:bodyPr>
+            <a:lstStyle/>
+            <a:p>
+              <a:pPr algn="l"/>
+              <a:r>
+                <a:rPr lang="zh-CN" sz="900" dirty="0">
+                  <a:solidFill>
+                    <a:srgbClr val="555555"/>
+                  </a:solidFill>
+                  <a:latin typeface="Arial"/>
+                  <a:ea typeface="Microsoft YaHei"/>
+                  <a:cs typeface="Arial"/>
+                </a:rPr>
+                <a:t>Pharmacists drive formulary decisions — engaging them is multiplying my reach to all MDs.</a:t>
+              </a:r>
+            </a:p>
+          </p:txBody>
+        </p:sp>
+        <p:sp>
+          <p:nvSpPr>
+            <p:cNvPr id="52" name="TextBox 52"/>
+            <p:cNvSpPr txBox="1"/>
+            <p:nvPr/>
+          </p:nvSpPr>
+          <p:spPr>
+            <a:xfrm>
+              <a:off x="464820" y="5617845"/>
+              <a:ext cx="5227310" cy="182880"/>
+            </a:xfrm>
+            <a:prstGeom prst="rect">
+              <a:avLst/>
+            </a:prstGeom>
+            <a:noFill/>
+            <a:ln>
+              <a:noFill/>
+            </a:ln>
+            <a:effectLst>
+              <a:outerShdw blurRad="76200" dist="19050" dir="5400000" algn="ctr" rotWithShape="0">
+                <a:srgbClr val="000000">
+                  <a:alpha val="5250"/>
+                </a:srgbClr>
+              </a:outerShdw>
+            </a:effectLst>
+          </p:spPr>
+          <p:txBody>
+            <a:bodyPr wrap="none" lIns="0" tIns="0" rIns="0" bIns="0" anchor="t" anchorCtr="0">
+              <a:spAutoFit/>
+            </a:bodyPr>
+            <a:lstStyle/>
+            <a:p>
+              <a:pPr algn="l"/>
+              <a:r>
+                <a:rPr lang="zh-CN" sz="900" b="1" dirty="0">
+                  <a:solidFill>
+                    <a:srgbClr val="AE232F"/>
+                  </a:solidFill>
+                  <a:latin typeface="Arial"/>
+                  <a:ea typeface="Microsoft YaHei"/>
+                  <a:cs typeface="Arial"/>
+                </a:rPr>
+                <a:t>Unique edge: Pharm.D. credential = peer-level credibility with hospital pharmacists.</a:t>
+              </a:r>
+            </a:p>
+          </p:txBody>
+        </p:sp>
+      </p:grpSp>
+      <p:grpSp>
+        <p:nvGrpSpPr>
+          <p:cNvPr id="72" name="Group 72"/>
+          <p:cNvGrpSpPr/>
+          <p:nvPr/>
+        </p:nvGrpSpPr>
+        <p:grpSpPr>
+          <a:xfrm>
+            <a:off x="6153150" y="876300"/>
+            <a:ext cx="5695950" cy="2552700"/>
+            <a:chOff x="6153150" y="876300"/>
+            <a:chExt cx="5695950" cy="2552700"/>
+          </a:xfrm>
+          <a:effectLst>
+            <a:outerShdw blurRad="76200" dist="19050" dir="5400000" algn="ctr" rotWithShape="0">
+              <a:srgbClr val="000000">
+                <a:alpha val="5250"/>
+              </a:srgbClr>
+            </a:outerShdw>
+          </a:effectLst>
+        </p:grpSpPr>
+        <p:sp>
+          <p:nvSpPr>
+            <p:cNvPr id="54" name="Rectangle 54"/>
+            <p:cNvSpPr/>
+            <p:nvPr/>
+          </p:nvSpPr>
+          <p:spPr>
+            <a:xfrm>
+              <a:off x="6153150" y="876300"/>
+              <a:ext cx="5695950" cy="2552700"/>
+            </a:xfrm>
+            <a:prstGeom prst="roundRect">
+              <a:avLst>
+                <a:gd name="adj" fmla="val 2985"/>
+              </a:avLst>
+            </a:prstGeom>
+            <a:solidFill>
+              <a:srgbClr val="FFFFFF"/>
+            </a:solidFill>
+            <a:ln w="9525">
+              <a:solidFill>
+                <a:srgbClr val="E0E0E0"/>
+              </a:solidFill>
+            </a:ln>
+            <a:effectLst>
+              <a:outerShdw blurRad="76200" dist="19050" dir="5400000" algn="ctr" rotWithShape="0">
+                <a:srgbClr val="000000">
+                  <a:alpha val="5250"/>
+                </a:srgbClr>
+              </a:outerShdw>
+            </a:effectLst>
+          </p:spPr>
+        </p:sp>
+        <p:sp>
+          <p:nvSpPr>
+            <p:cNvPr id="55" name="Rectangle 55"/>
+            <p:cNvSpPr/>
+            <p:nvPr/>
+          </p:nvSpPr>
+          <p:spPr>
+            <a:xfrm>
+              <a:off x="6153150" y="876300"/>
+              <a:ext cx="47625" cy="2552700"/>
+            </a:xfrm>
+            <a:prstGeom prst="roundRect">
+              <a:avLst>
+                <a:gd name="adj" fmla="val 50000"/>
+              </a:avLst>
+            </a:prstGeom>
+            <a:solidFill>
+              <a:srgbClr val="E0E0E0"/>
+            </a:solidFill>
+            <a:ln>
+              <a:noFill/>
+            </a:ln>
+            <a:effectLst>
+              <a:outerShdw blurRad="76200" dist="19050" dir="5400000" algn="ctr" rotWithShape="0">
+                <a:srgbClr val="000000">
+                  <a:alpha val="5250"/>
+                </a:srgbClr>
+              </a:outerShdw>
+            </a:effectLst>
+          </p:spPr>
+        </p:sp>
+        <p:sp>
+          <p:nvSpPr>
+            <p:cNvPr id="56" name="Rectangle 56"/>
+            <p:cNvSpPr/>
+            <p:nvPr/>
+          </p:nvSpPr>
+          <p:spPr>
+            <a:xfrm>
+              <a:off x="11277600" y="952500"/>
+              <a:ext cx="457200" cy="209550"/>
+            </a:xfrm>
+            <a:prstGeom prst="roundRect">
+              <a:avLst>
+                <a:gd name="adj" fmla="val 18182"/>
+              </a:avLst>
+            </a:prstGeom>
+            <a:solidFill>
+              <a:srgbClr val="F9E5E7"/>
+            </a:solidFill>
+            <a:ln w="9525">
+              <a:solidFill>
+                <a:srgbClr val="AE232F"/>
+              </a:solidFill>
+            </a:ln>
+            <a:effectLst>
+              <a:outerShdw blurRad="76200" dist="19050" dir="5400000" algn="ctr" rotWithShape="0">
+                <a:srgbClr val="000000">
+                  <a:alpha val="5250"/>
+                </a:srgbClr>
+              </a:outerShdw>
+            </a:effectLst>
+          </p:spPr>
+        </p:sp>
+        <p:sp>
+          <p:nvSpPr>
+            <p:cNvPr id="57" name="TextBox 57"/>
+            <p:cNvSpPr txBox="1"/>
+            <p:nvPr/>
+          </p:nvSpPr>
+          <p:spPr>
+            <a:xfrm>
+              <a:off x="11334002" y="1006316"/>
+              <a:ext cx="344395" cy="167640"/>
+            </a:xfrm>
+            <a:prstGeom prst="rect">
+              <a:avLst/>
+            </a:prstGeom>
+            <a:noFill/>
+            <a:ln>
+              <a:noFill/>
+            </a:ln>
+            <a:effectLst>
+              <a:outerShdw blurRad="76200" dist="19050" dir="5400000" algn="ctr" rotWithShape="0">
+                <a:srgbClr val="000000">
+                  <a:alpha val="5250"/>
+                </a:srgbClr>
+              </a:outerShdw>
+            </a:effectLst>
+          </p:spPr>
+          <p:txBody>
+            <a:bodyPr wrap="none" lIns="0" tIns="0" rIns="0" bIns="0" anchor="t" anchorCtr="0">
+              <a:spAutoFit/>
+            </a:bodyPr>
+            <a:lstStyle/>
+            <a:p>
+              <a:pPr algn="ctr"/>
+              <a:r>
+                <a:rPr lang="zh-CN" sz="825" b="1" dirty="0">
+                  <a:solidFill>
+                    <a:srgbClr val="AE232F"/>
+                  </a:solidFill>
+                  <a:latin typeface="Arial"/>
+                  <a:ea typeface="Microsoft YaHei"/>
+                  <a:cs typeface="Arial"/>
+                </a:rPr>
+                <a:t>Tier B</a:t>
+              </a:r>
+            </a:p>
+          </p:txBody>
+        </p:sp>
+        <p:sp>
+          <p:nvSpPr>
+            <p:cNvPr id="58" name="Ellipse 58"/>
+            <p:cNvSpPr/>
+            <p:nvPr/>
+          </p:nvSpPr>
+          <p:spPr>
+            <a:xfrm>
+              <a:off x="6286500" y="1085850"/>
+              <a:ext cx="419100" cy="419100"/>
+            </a:xfrm>
+            <a:prstGeom prst="ellipse">
+              <a:avLst/>
+            </a:prstGeom>
+            <a:solidFill>
+              <a:srgbClr val="F5F5F5"/>
+            </a:solidFill>
+            <a:ln>
+              <a:noFill/>
+            </a:ln>
+            <a:effectLst>
+              <a:outerShdw blurRad="76200" dist="19050" dir="5400000" algn="ctr" rotWithShape="0">
+                <a:srgbClr val="000000">
+                  <a:alpha val="5250"/>
+                </a:srgbClr>
+              </a:outerShdw>
+            </a:effectLst>
+          </p:spPr>
+        </p:sp>
+        <p:sp>
+          <p:nvSpPr>
+            <p:cNvPr id="59" name="Freeform 59"/>
+            <p:cNvSpPr/>
+            <p:nvPr/>
+          </p:nvSpPr>
+          <p:spPr>
+            <a:xfrm>
+              <a:off x="6403541" y="1200150"/>
+              <a:ext cx="185019" cy="190500"/>
+            </a:xfrm>
+            <a:custGeom>
+              <a:avLst/>
+              <a:gdLst/>
+              <a:ahLst/>
+              <a:cxnLst/>
+              <a:rect l="l" t="t" r="r" b="b"/>
+              <a:pathLst>
+                <a:path w="185019" h="190500">
+                  <a:moveTo>
+                    <a:pt x="82984" y="0"/>
+                  </a:moveTo>
+                  <a:lnTo>
+                    <a:pt x="81556" y="48"/>
+                  </a:lnTo>
+                  <a:cubicBezTo>
+                    <a:pt x="71614" y="795"/>
+                    <a:pt x="63931" y="9081"/>
+                    <a:pt x="63934" y="19050"/>
+                  </a:cubicBezTo>
+                  <a:lnTo>
+                    <a:pt x="63934" y="45749"/>
+                  </a:lnTo>
+                  <a:lnTo>
+                    <a:pt x="40808" y="32404"/>
+                  </a:lnTo>
+                  <a:cubicBezTo>
+                    <a:pt x="31696" y="27144"/>
+                    <a:pt x="20046" y="30265"/>
+                    <a:pt x="14785" y="39376"/>
+                  </a:cubicBezTo>
+                  <a:lnTo>
+                    <a:pt x="5260" y="55874"/>
+                  </a:lnTo>
+                  <a:lnTo>
+                    <a:pt x="4565" y="57188"/>
+                  </a:lnTo>
+                  <a:cubicBezTo>
+                    <a:pt x="279" y="66163"/>
+                    <a:pt x="3619" y="76924"/>
+                    <a:pt x="12233" y="81896"/>
+                  </a:cubicBezTo>
+                  <a:lnTo>
+                    <a:pt x="35350" y="95250"/>
+                  </a:lnTo>
+                  <a:lnTo>
+                    <a:pt x="12233" y="108604"/>
+                  </a:lnTo>
+                  <a:cubicBezTo>
+                    <a:pt x="3122" y="113865"/>
+                    <a:pt x="0" y="125515"/>
+                    <a:pt x="5260" y="134626"/>
+                  </a:cubicBezTo>
+                  <a:lnTo>
+                    <a:pt x="14785" y="151124"/>
+                  </a:lnTo>
+                  <a:lnTo>
+                    <a:pt x="15576" y="152381"/>
+                  </a:lnTo>
+                  <a:cubicBezTo>
+                    <a:pt x="21205" y="160580"/>
+                    <a:pt x="32195" y="163070"/>
+                    <a:pt x="40808" y="158096"/>
+                  </a:cubicBezTo>
+                  <a:lnTo>
+                    <a:pt x="63934" y="144742"/>
+                  </a:lnTo>
+                  <a:lnTo>
+                    <a:pt x="63934" y="171450"/>
+                  </a:lnTo>
+                  <a:cubicBezTo>
+                    <a:pt x="63934" y="181971"/>
+                    <a:pt x="72463" y="190500"/>
+                    <a:pt x="82984" y="190500"/>
+                  </a:cubicBezTo>
+                  <a:lnTo>
+                    <a:pt x="102034" y="190500"/>
+                  </a:lnTo>
+                  <a:lnTo>
+                    <a:pt x="103463" y="190452"/>
+                  </a:lnTo>
+                  <a:cubicBezTo>
+                    <a:pt x="113404" y="189705"/>
+                    <a:pt x="121087" y="181419"/>
+                    <a:pt x="121084" y="171450"/>
+                  </a:cubicBezTo>
+                  <a:lnTo>
+                    <a:pt x="121084" y="144742"/>
+                  </a:lnTo>
+                  <a:lnTo>
+                    <a:pt x="144211" y="158105"/>
+                  </a:lnTo>
+                  <a:cubicBezTo>
+                    <a:pt x="153322" y="163366"/>
+                    <a:pt x="164973" y="160244"/>
+                    <a:pt x="170233" y="151133"/>
+                  </a:cubicBezTo>
+                  <a:lnTo>
+                    <a:pt x="179758" y="134636"/>
+                  </a:lnTo>
+                  <a:lnTo>
+                    <a:pt x="180454" y="133321"/>
+                  </a:lnTo>
+                  <a:cubicBezTo>
+                    <a:pt x="184739" y="124347"/>
+                    <a:pt x="181400" y="113585"/>
+                    <a:pt x="172786" y="108614"/>
+                  </a:cubicBezTo>
+                  <a:lnTo>
+                    <a:pt x="149659" y="95250"/>
+                  </a:lnTo>
+                  <a:lnTo>
+                    <a:pt x="172786" y="81896"/>
+                  </a:lnTo>
+                  <a:cubicBezTo>
+                    <a:pt x="181897" y="76635"/>
+                    <a:pt x="185019" y="64985"/>
+                    <a:pt x="179758" y="55874"/>
+                  </a:cubicBezTo>
+                  <a:lnTo>
+                    <a:pt x="170233" y="39376"/>
+                  </a:lnTo>
+                  <a:lnTo>
+                    <a:pt x="169443" y="38119"/>
+                  </a:lnTo>
+                  <a:cubicBezTo>
+                    <a:pt x="163814" y="29920"/>
+                    <a:pt x="152824" y="27430"/>
+                    <a:pt x="144211" y="32404"/>
+                  </a:cubicBezTo>
+                  <a:lnTo>
+                    <a:pt x="121084" y="45739"/>
+                  </a:lnTo>
+                  <a:lnTo>
+                    <a:pt x="121084" y="19050"/>
+                  </a:lnTo>
+                  <a:cubicBezTo>
+                    <a:pt x="121084" y="8529"/>
+                    <a:pt x="112555" y="0"/>
+                    <a:pt x="102034" y="0"/>
+                  </a:cubicBezTo>
+                  <a:lnTo>
+                    <a:pt x="82984" y="0"/>
+                  </a:lnTo>
+                  <a:close/>
+                </a:path>
+              </a:pathLst>
+            </a:custGeom>
+            <a:solidFill>
+              <a:srgbClr val="888888"/>
+            </a:solidFill>
+            <a:ln>
+              <a:noFill/>
+            </a:ln>
+            <a:effectLst>
+              <a:outerShdw blurRad="76200" dist="19050" dir="5400000" algn="ctr" rotWithShape="0">
+                <a:srgbClr val="000000">
+                  <a:alpha val="5250"/>
+                </a:srgbClr>
+              </a:outerShdw>
+            </a:effectLst>
+          </p:spPr>
+        </p:sp>
+        <p:sp>
+          <p:nvSpPr>
+            <p:cNvPr id="60" name="TextBox 60"/>
+            <p:cNvSpPr txBox="1"/>
+            <p:nvPr/>
+          </p:nvSpPr>
+          <p:spPr>
+            <a:xfrm>
+              <a:off x="6805612" y="1116806"/>
+              <a:ext cx="2832425" cy="228600"/>
+            </a:xfrm>
+            <a:prstGeom prst="rect">
+              <a:avLst/>
+            </a:prstGeom>
+            <a:noFill/>
+            <a:ln>
+              <a:noFill/>
+            </a:ln>
+            <a:effectLst>
+              <a:outerShdw blurRad="76200" dist="19050" dir="5400000" algn="ctr" rotWithShape="0">
+                <a:srgbClr val="000000">
+                  <a:alpha val="5250"/>
+                </a:srgbClr>
+              </a:outerShdw>
+            </a:effectLst>
+          </p:spPr>
+          <p:txBody>
+            <a:bodyPr wrap="none" lIns="0" tIns="0" rIns="0" bIns="0" anchor="t" anchorCtr="0">
+              <a:spAutoFit/>
+            </a:bodyPr>
+            <a:lstStyle/>
+            <a:p>
+              <a:pPr algn="l"/>
+              <a:r>
+                <a:rPr lang="zh-CN" sz="1125" b="1" dirty="0">
+                  <a:solidFill>
+                    <a:srgbClr val="1A1A1A"/>
+                  </a:solidFill>
+                  <a:latin typeface="Arial"/>
+                  <a:ea typeface="Microsoft YaHei"/>
+                  <a:cs typeface="Arial"/>
+                </a:rPr>
+                <a:t>Internal Medicine / General Physician</a:t>
+              </a:r>
+            </a:p>
+          </p:txBody>
+        </p:sp>
+        <p:sp>
+          <p:nvSpPr>
+            <p:cNvPr id="61" name="TextBox 61"/>
+            <p:cNvSpPr txBox="1"/>
+            <p:nvPr/>
+          </p:nvSpPr>
+          <p:spPr>
+            <a:xfrm>
+              <a:off x="6809422" y="1320641"/>
+              <a:ext cx="3659660" cy="167640"/>
+            </a:xfrm>
+            <a:prstGeom prst="rect">
+              <a:avLst/>
+            </a:prstGeom>
+            <a:noFill/>
+            <a:ln>
+              <a:noFill/>
+            </a:ln>
+            <a:effectLst>
+              <a:outerShdw blurRad="76200" dist="19050" dir="5400000" algn="ctr" rotWithShape="0">
+                <a:srgbClr val="000000">
+                  <a:alpha val="5250"/>
+                </a:srgbClr>
+              </a:outerShdw>
+            </a:effectLst>
+          </p:spPr>
+          <p:txBody>
+            <a:bodyPr wrap="none" lIns="0" tIns="0" rIns="0" bIns="0" anchor="t" anchorCtr="0">
+              <a:spAutoFit/>
+            </a:bodyPr>
+            <a:lstStyle/>
+            <a:p>
+              <a:pPr algn="l"/>
+              <a:r>
+                <a:rPr lang="zh-CN" sz="825" b="1" dirty="0">
+                  <a:solidFill>
+                    <a:srgbClr val="555555"/>
+                  </a:solidFill>
+                  <a:latin typeface="Arial"/>
+                  <a:ea typeface="Microsoft YaHei"/>
+                  <a:cs typeface="Arial"/>
+                </a:rPr>
+                <a:t>Clexane role: DVT prophylaxis for immobile medical ward patients</a:t>
+              </a:r>
+            </a:p>
+          </p:txBody>
+        </p:sp>
+        <p:sp>
+          <p:nvSpPr>
+            <p:cNvPr id="62" name="Line 62"/>
+            <p:cNvSpPr/>
+            <p:nvPr/>
+          </p:nvSpPr>
+          <p:spPr>
+            <a:xfrm>
+              <a:off x="6286500" y="1533525"/>
+              <a:ext cx="5448300" cy="9525"/>
+            </a:xfrm>
+            <a:custGeom>
+              <a:avLst/>
+              <a:gdLst/>
+              <a:ahLst/>
+              <a:cxnLst/>
+              <a:rect l="l" t="t" r="r" b="b"/>
+              <a:pathLst>
+                <a:path w="5448300" h="9525">
+                  <a:moveTo>
+                    <a:pt x="0" y="0"/>
+                  </a:moveTo>
+                  <a:lnTo>
+                    <a:pt x="5448300" y="0"/>
+                  </a:lnTo>
+                </a:path>
+              </a:pathLst>
+            </a:custGeom>
+            <a:noFill/>
+            <a:ln w="9525">
+              <a:solidFill>
+                <a:srgbClr val="F5F5F5"/>
+              </a:solidFill>
+            </a:ln>
+          </p:spPr>
+        </p:sp>
+        <p:sp>
+          <p:nvSpPr>
+            <p:cNvPr id="63" name="TextBox 63"/>
+            <p:cNvSpPr txBox="1"/>
+            <p:nvPr/>
+          </p:nvSpPr>
+          <p:spPr>
+            <a:xfrm>
+              <a:off x="6275070" y="1636395"/>
+              <a:ext cx="848263" cy="182880"/>
+            </a:xfrm>
+            <a:prstGeom prst="rect">
+              <a:avLst/>
+            </a:prstGeom>
+            <a:noFill/>
+            <a:ln>
+              <a:noFill/>
+            </a:ln>
+            <a:effectLst>
+              <a:outerShdw blurRad="76200" dist="19050" dir="5400000" algn="ctr" rotWithShape="0">
+                <a:srgbClr val="000000">
+                  <a:alpha val="5250"/>
+                </a:srgbClr>
+              </a:outerShdw>
+            </a:effectLst>
+          </p:spPr>
+          <p:txBody>
+            <a:bodyPr wrap="none" lIns="0" tIns="0" rIns="0" bIns="0" anchor="t" anchorCtr="0">
+              <a:spAutoFit/>
+            </a:bodyPr>
+            <a:lstStyle/>
+            <a:p>
+              <a:pPr algn="l"/>
+              <a:r>
+                <a:rPr lang="zh-CN" sz="900" b="1" dirty="0">
+                  <a:solidFill>
+                    <a:srgbClr val="555555"/>
+                  </a:solidFill>
+                  <a:latin typeface="Arial"/>
+                  <a:ea typeface="Microsoft YaHei"/>
+                  <a:cs typeface="Arial"/>
+                </a:rPr>
+                <a:t>Key message:</a:t>
+              </a:r>
+            </a:p>
+          </p:txBody>
+        </p:sp>
+        <p:sp>
+          <p:nvSpPr>
+            <p:cNvPr id="64" name="TextBox 64"/>
+            <p:cNvSpPr txBox="1"/>
+            <p:nvPr/>
+          </p:nvSpPr>
+          <p:spPr>
+            <a:xfrm>
+              <a:off x="6275070" y="1807845"/>
+              <a:ext cx="3923348" cy="182880"/>
+            </a:xfrm>
+            <a:prstGeom prst="rect">
+              <a:avLst/>
+            </a:prstGeom>
+            <a:noFill/>
+            <a:ln>
+              <a:noFill/>
+            </a:ln>
+            <a:effectLst>
+              <a:outerShdw blurRad="76200" dist="19050" dir="5400000" algn="ctr" rotWithShape="0">
+                <a:srgbClr val="000000">
+                  <a:alpha val="5250"/>
+                </a:srgbClr>
+              </a:outerShdw>
+            </a:effectLst>
+          </p:spPr>
+          <p:txBody>
+            <a:bodyPr wrap="none" lIns="0" tIns="0" rIns="0" bIns="0" anchor="t" anchorCtr="0">
+              <a:spAutoFit/>
+            </a:bodyPr>
+            <a:lstStyle/>
+            <a:p>
+              <a:pPr algn="l"/>
+              <a:r>
+                <a:rPr lang="zh-CN" sz="900" dirty="0">
+                  <a:solidFill>
+                    <a:srgbClr val="555555"/>
+                  </a:solidFill>
+                  <a:latin typeface="Arial"/>
+                  <a:ea typeface="Microsoft YaHei"/>
+                  <a:cs typeface="Arial"/>
+                </a:rPr>
+                <a:t>Simple once-daily dosing (40 mg SC q24h prophylaxis) — suitable for</a:t>
+              </a:r>
+            </a:p>
+          </p:txBody>
+        </p:sp>
+        <p:sp>
+          <p:nvSpPr>
+            <p:cNvPr id="65" name="TextBox 65"/>
+            <p:cNvSpPr txBox="1"/>
+            <p:nvPr/>
+          </p:nvSpPr>
+          <p:spPr>
+            <a:xfrm>
+              <a:off x="6275070" y="1979295"/>
+              <a:ext cx="4157377" cy="182880"/>
+            </a:xfrm>
+            <a:prstGeom prst="rect">
+              <a:avLst/>
+            </a:prstGeom>
+            <a:noFill/>
+            <a:ln>
+              <a:noFill/>
+            </a:ln>
+            <a:effectLst>
+              <a:outerShdw blurRad="76200" dist="19050" dir="5400000" algn="ctr" rotWithShape="0">
+                <a:srgbClr val="000000">
+                  <a:alpha val="5250"/>
+                </a:srgbClr>
+              </a:outerShdw>
+            </a:effectLst>
+          </p:spPr>
+          <p:txBody>
+            <a:bodyPr wrap="none" lIns="0" tIns="0" rIns="0" bIns="0" anchor="t" anchorCtr="0">
+              <a:spAutoFit/>
+            </a:bodyPr>
+            <a:lstStyle/>
+            <a:p>
+              <a:pPr algn="l"/>
+              <a:r>
+                <a:rPr lang="zh-CN" sz="900" dirty="0">
+                  <a:solidFill>
+                    <a:srgbClr val="555555"/>
+                  </a:solidFill>
+                  <a:latin typeface="Arial"/>
+                  <a:ea typeface="Microsoft YaHei"/>
+                  <a:cs typeface="Arial"/>
+                </a:rPr>
+                <a:t>high-risk medical inpatients: heart failure, stroke, severe infection.</a:t>
+              </a:r>
+            </a:p>
+          </p:txBody>
+        </p:sp>
+        <p:sp>
+          <p:nvSpPr>
+            <p:cNvPr id="66" name="TextBox 66"/>
+            <p:cNvSpPr txBox="1"/>
+            <p:nvPr/>
+          </p:nvSpPr>
+          <p:spPr>
+            <a:xfrm>
+              <a:off x="6275070" y="2207895"/>
+              <a:ext cx="3893344" cy="182880"/>
+            </a:xfrm>
+            <a:prstGeom prst="rect">
+              <a:avLst/>
+            </a:prstGeom>
+            <a:noFill/>
+            <a:ln>
+              <a:noFill/>
+            </a:ln>
+            <a:effectLst>
+              <a:outerShdw blurRad="76200" dist="19050" dir="5400000" algn="ctr" rotWithShape="0">
+                <a:srgbClr val="000000">
+                  <a:alpha val="5250"/>
+                </a:srgbClr>
+              </a:outerShdw>
+            </a:effectLst>
+          </p:spPr>
+          <p:txBody>
+            <a:bodyPr wrap="none" lIns="0" tIns="0" rIns="0" bIns="0" anchor="t" anchorCtr="0">
+              <a:spAutoFit/>
+            </a:bodyPr>
+            <a:lstStyle/>
+            <a:p>
+              <a:pPr algn="l"/>
+              <a:r>
+                <a:rPr lang="zh-CN" sz="900" dirty="0">
+                  <a:solidFill>
+                    <a:srgbClr val="555555"/>
+                  </a:solidFill>
+                  <a:latin typeface="Arial"/>
+                  <a:ea typeface="Microsoft YaHei"/>
+                  <a:cs typeface="Arial"/>
+                </a:rPr>
+                <a:t>MEDENOX trial: Clexane 40 mg q24h reduced VTE by 63% vs. placebo</a:t>
+              </a:r>
+            </a:p>
+          </p:txBody>
+        </p:sp>
+        <p:sp>
+          <p:nvSpPr>
+            <p:cNvPr id="67" name="TextBox 67"/>
+            <p:cNvSpPr txBox="1"/>
+            <p:nvPr/>
+          </p:nvSpPr>
+          <p:spPr>
+            <a:xfrm>
+              <a:off x="6275070" y="2379345"/>
+              <a:ext cx="3731324" cy="182880"/>
+            </a:xfrm>
+            <a:prstGeom prst="rect">
+              <a:avLst/>
+            </a:prstGeom>
+            <a:noFill/>
+            <a:ln>
+              <a:noFill/>
+            </a:ln>
+            <a:effectLst>
+              <a:outerShdw blurRad="76200" dist="19050" dir="5400000" algn="ctr" rotWithShape="0">
+                <a:srgbClr val="000000">
+                  <a:alpha val="5250"/>
+                </a:srgbClr>
+              </a:outerShdw>
+            </a:effectLst>
+          </p:spPr>
+          <p:txBody>
+            <a:bodyPr wrap="none" lIns="0" tIns="0" rIns="0" bIns="0" anchor="t" anchorCtr="0">
+              <a:spAutoFit/>
+            </a:bodyPr>
+            <a:lstStyle/>
+            <a:p>
+              <a:pPr algn="l"/>
+              <a:r>
+                <a:rPr lang="zh-CN" sz="900" dirty="0">
+                  <a:solidFill>
+                    <a:srgbClr val="555555"/>
+                  </a:solidFill>
+                  <a:latin typeface="Arial"/>
+                  <a:ea typeface="Microsoft YaHei"/>
+                  <a:cs typeface="Arial"/>
+                </a:rPr>
+                <a:t>in acutely ill medical patients. Well-established safety profile.</a:t>
+              </a:r>
+            </a:p>
+          </p:txBody>
+        </p:sp>
+        <p:sp>
+          <p:nvSpPr>
+            <p:cNvPr id="68" name="Rectangle 68"/>
+            <p:cNvSpPr/>
+            <p:nvPr/>
+          </p:nvSpPr>
+          <p:spPr>
+            <a:xfrm>
+              <a:off x="6286500" y="2647950"/>
+              <a:ext cx="5410200" cy="609600"/>
+            </a:xfrm>
+            <a:prstGeom prst="roundRect">
+              <a:avLst>
+                <a:gd name="adj" fmla="val 9375"/>
+              </a:avLst>
+            </a:prstGeom>
+            <a:solidFill>
+              <a:srgbClr val="F5F5F5"/>
+            </a:solidFill>
+            <a:ln>
+              <a:noFill/>
+            </a:ln>
+            <a:effectLst>
+              <a:outerShdw blurRad="76200" dist="19050" dir="5400000" algn="ctr" rotWithShape="0">
+                <a:srgbClr val="000000">
+                  <a:alpha val="5250"/>
+                </a:srgbClr>
+              </a:outerShdw>
+            </a:effectLst>
+          </p:spPr>
+        </p:sp>
+        <p:sp>
+          <p:nvSpPr>
+            <p:cNvPr id="69" name="TextBox 69"/>
+            <p:cNvSpPr txBox="1"/>
+            <p:nvPr/>
+          </p:nvSpPr>
+          <p:spPr>
+            <a:xfrm>
+              <a:off x="7452229" y="2741295"/>
+              <a:ext cx="3078742" cy="182880"/>
+            </a:xfrm>
+            <a:prstGeom prst="rect">
+              <a:avLst/>
+            </a:prstGeom>
+            <a:noFill/>
+            <a:ln>
+              <a:noFill/>
+            </a:ln>
+            <a:effectLst>
+              <a:outerShdw blurRad="76200" dist="19050" dir="5400000" algn="ctr" rotWithShape="0">
+                <a:srgbClr val="000000">
+                  <a:alpha val="5250"/>
+                </a:srgbClr>
+              </a:outerShdw>
+            </a:effectLst>
+          </p:spPr>
+          <p:txBody>
+            <a:bodyPr wrap="none" lIns="0" tIns="0" rIns="0" bIns="0" anchor="t" anchorCtr="0">
+              <a:spAutoFit/>
+            </a:bodyPr>
+            <a:lstStyle/>
+            <a:p>
+              <a:pPr algn="ctr"/>
+              <a:r>
+                <a:rPr lang="zh-CN" sz="900" b="1" dirty="0">
+                  <a:solidFill>
+                    <a:srgbClr val="555555"/>
+                  </a:solidFill>
+                  <a:latin typeface="Arial"/>
+                  <a:ea typeface="Microsoft YaHei"/>
+                  <a:cs typeface="Arial"/>
+                </a:rPr>
+                <a:t>Padua Prediction Score ≥ 4 → prophylaxis indicated</a:t>
+              </a:r>
+            </a:p>
+          </p:txBody>
+        </p:sp>
+        <p:sp>
+          <p:nvSpPr>
+            <p:cNvPr id="70" name="TextBox 70"/>
+            <p:cNvSpPr txBox="1"/>
+            <p:nvPr/>
+          </p:nvSpPr>
+          <p:spPr>
+            <a:xfrm>
+              <a:off x="7215402" y="2920841"/>
+              <a:ext cx="3552396" cy="167640"/>
+            </a:xfrm>
+            <a:prstGeom prst="rect">
+              <a:avLst/>
+            </a:prstGeom>
+            <a:noFill/>
+            <a:ln>
+              <a:noFill/>
+            </a:ln>
+            <a:effectLst>
+              <a:outerShdw blurRad="76200" dist="19050" dir="5400000" algn="ctr" rotWithShape="0">
+                <a:srgbClr val="000000">
+                  <a:alpha val="5250"/>
+                </a:srgbClr>
+              </a:outerShdw>
+            </a:effectLst>
+          </p:spPr>
+          <p:txBody>
+            <a:bodyPr wrap="none" lIns="0" tIns="0" rIns="0" bIns="0" anchor="t" anchorCtr="0">
+              <a:spAutoFit/>
+            </a:bodyPr>
+            <a:lstStyle/>
+            <a:p>
+              <a:pPr algn="ctr"/>
+              <a:r>
+                <a:rPr lang="zh-CN" sz="825" dirty="0">
+                  <a:solidFill>
+                    <a:srgbClr val="888888"/>
+                  </a:solidFill>
+                  <a:latin typeface="Arial"/>
+                  <a:ea typeface="Microsoft YaHei"/>
+                  <a:cs typeface="Arial"/>
+                </a:rPr>
+                <a:t>I will help MDs identify eligible patients using the Padua score tool</a:t>
+              </a:r>
+            </a:p>
+          </p:txBody>
+        </p:sp>
+        <p:sp>
+          <p:nvSpPr>
+            <p:cNvPr id="71" name="TextBox 71"/>
+            <p:cNvSpPr txBox="1"/>
+            <p:nvPr/>
+          </p:nvSpPr>
+          <p:spPr>
+            <a:xfrm>
+              <a:off x="7647206" y="3073241"/>
+              <a:ext cx="2688788" cy="167640"/>
+            </a:xfrm>
+            <a:prstGeom prst="rect">
+              <a:avLst/>
+            </a:prstGeom>
+            <a:noFill/>
+            <a:ln>
+              <a:noFill/>
+            </a:ln>
+            <a:effectLst>
+              <a:outerShdw blurRad="76200" dist="19050" dir="5400000" algn="ctr" rotWithShape="0">
+                <a:srgbClr val="000000">
+                  <a:alpha val="5250"/>
+                </a:srgbClr>
+              </a:outerShdw>
+            </a:effectLst>
+          </p:spPr>
+          <p:txBody>
+            <a:bodyPr wrap="none" lIns="0" tIns="0" rIns="0" bIns="0" anchor="t" anchorCtr="0">
+              <a:spAutoFit/>
+            </a:bodyPr>
+            <a:lstStyle/>
+            <a:p>
+              <a:pPr algn="ctr"/>
+              <a:r>
+                <a:rPr lang="zh-CN" sz="825" dirty="0">
+                  <a:solidFill>
+                    <a:srgbClr val="888888"/>
+                  </a:solidFill>
+                  <a:latin typeface="Arial"/>
+                  <a:ea typeface="Microsoft YaHei"/>
+                  <a:cs typeface="Arial"/>
+                </a:rPr>
+                <a:t>and link it directly to the Clexane 40 mg protocol.</a:t>
+              </a:r>
+            </a:p>
+          </p:txBody>
+        </p:sp>
+      </p:grpSp>
+      <p:grpSp>
+        <p:nvGrpSpPr>
+          <p:cNvPr id="90" name="Group 90"/>
+          <p:cNvGrpSpPr/>
+          <p:nvPr/>
+        </p:nvGrpSpPr>
+        <p:grpSpPr>
+          <a:xfrm>
+            <a:off x="6153150" y="3543300"/>
+            <a:ext cx="5695950" cy="2362200"/>
+            <a:chOff x="6153150" y="3543300"/>
+            <a:chExt cx="5695950" cy="2362200"/>
+          </a:xfrm>
+          <a:effectLst>
+            <a:outerShdw blurRad="76200" dist="19050" dir="5400000" algn="ctr" rotWithShape="0">
+              <a:srgbClr val="000000">
+                <a:alpha val="5250"/>
+              </a:srgbClr>
+            </a:outerShdw>
+          </a:effectLst>
+        </p:grpSpPr>
+        <p:sp>
+          <p:nvSpPr>
+            <p:cNvPr id="73" name="Rectangle 73"/>
+            <p:cNvSpPr/>
+            <p:nvPr/>
+          </p:nvSpPr>
+          <p:spPr>
+            <a:xfrm>
+              <a:off x="6153150" y="3543300"/>
+              <a:ext cx="5695950" cy="2362200"/>
+            </a:xfrm>
+            <a:prstGeom prst="roundRect">
+              <a:avLst>
+                <a:gd name="adj" fmla="val 3226"/>
+              </a:avLst>
+            </a:prstGeom>
+            <a:solidFill>
+              <a:srgbClr val="FFFFFF"/>
+            </a:solidFill>
+            <a:ln w="9525">
+              <a:solidFill>
+                <a:srgbClr val="E0E0E0"/>
+              </a:solidFill>
+            </a:ln>
+            <a:effectLst>
+              <a:outerShdw blurRad="76200" dist="19050" dir="5400000" algn="ctr" rotWithShape="0">
+                <a:srgbClr val="000000">
+                  <a:alpha val="5250"/>
+                </a:srgbClr>
+              </a:outerShdw>
+            </a:effectLst>
+          </p:spPr>
+        </p:sp>
+        <p:sp>
+          <p:nvSpPr>
+            <p:cNvPr id="74" name="Rectangle 74"/>
+            <p:cNvSpPr/>
+            <p:nvPr/>
+          </p:nvSpPr>
+          <p:spPr>
+            <a:xfrm>
+              <a:off x="6153150" y="3543300"/>
+              <a:ext cx="47625" cy="2362200"/>
+            </a:xfrm>
+            <a:prstGeom prst="roundRect">
+              <a:avLst>
+                <a:gd name="adj" fmla="val 50000"/>
+              </a:avLst>
+            </a:prstGeom>
+            <a:solidFill>
+              <a:srgbClr val="E0E0E0"/>
+            </a:solidFill>
+            <a:ln>
+              <a:noFill/>
+            </a:ln>
+            <a:effectLst>
+              <a:outerShdw blurRad="76200" dist="19050" dir="5400000" algn="ctr" rotWithShape="0">
+                <a:srgbClr val="000000">
+                  <a:alpha val="5250"/>
+                </a:srgbClr>
+              </a:outerShdw>
+            </a:effectLst>
+          </p:spPr>
+        </p:sp>
+        <p:sp>
+          <p:nvSpPr>
+            <p:cNvPr id="75" name="Rectangle 75"/>
+            <p:cNvSpPr/>
+            <p:nvPr/>
+          </p:nvSpPr>
+          <p:spPr>
+            <a:xfrm>
+              <a:off x="11277600" y="3619500"/>
+              <a:ext cx="457200" cy="209550"/>
+            </a:xfrm>
+            <a:prstGeom prst="roundRect">
+              <a:avLst>
+                <a:gd name="adj" fmla="val 18182"/>
+              </a:avLst>
+            </a:prstGeom>
+            <a:solidFill>
+              <a:srgbClr val="F9E5E7"/>
+            </a:solidFill>
+            <a:ln w="9525">
+              <a:solidFill>
+                <a:srgbClr val="AE232F"/>
+              </a:solidFill>
+            </a:ln>
+            <a:effectLst>
+              <a:outerShdw blurRad="76200" dist="19050" dir="5400000" algn="ctr" rotWithShape="0">
+                <a:srgbClr val="000000">
+                  <a:alpha val="5250"/>
+                </a:srgbClr>
+              </a:outerShdw>
+            </a:effectLst>
+          </p:spPr>
+        </p:sp>
+        <p:sp>
+          <p:nvSpPr>
+            <p:cNvPr id="76" name="TextBox 76"/>
+            <p:cNvSpPr txBox="1"/>
+            <p:nvPr/>
+          </p:nvSpPr>
+          <p:spPr>
+            <a:xfrm>
+              <a:off x="11334002" y="3673316"/>
+              <a:ext cx="344395" cy="167640"/>
+            </a:xfrm>
+            <a:prstGeom prst="rect">
+              <a:avLst/>
+            </a:prstGeom>
+            <a:noFill/>
+            <a:ln>
+              <a:noFill/>
+            </a:ln>
+            <a:effectLst>
+              <a:outerShdw blurRad="76200" dist="19050" dir="5400000" algn="ctr" rotWithShape="0">
+                <a:srgbClr val="000000">
+                  <a:alpha val="5250"/>
+                </a:srgbClr>
+              </a:outerShdw>
+            </a:effectLst>
+          </p:spPr>
+          <p:txBody>
+            <a:bodyPr wrap="none" lIns="0" tIns="0" rIns="0" bIns="0" anchor="t" anchorCtr="0">
+              <a:spAutoFit/>
+            </a:bodyPr>
+            <a:lstStyle/>
+            <a:p>
+              <a:pPr algn="ctr"/>
+              <a:r>
+                <a:rPr lang="zh-CN" sz="825" b="1" dirty="0">
+                  <a:solidFill>
+                    <a:srgbClr val="AE232F"/>
+                  </a:solidFill>
+                  <a:latin typeface="Arial"/>
+                  <a:ea typeface="Microsoft YaHei"/>
+                  <a:cs typeface="Arial"/>
+                </a:rPr>
+                <a:t>Tier B</a:t>
+              </a:r>
+            </a:p>
+          </p:txBody>
+        </p:sp>
+        <p:sp>
+          <p:nvSpPr>
+            <p:cNvPr id="77" name="Ellipse 77"/>
+            <p:cNvSpPr/>
+            <p:nvPr/>
+          </p:nvSpPr>
+          <p:spPr>
+            <a:xfrm>
+              <a:off x="6286500" y="3752850"/>
+              <a:ext cx="419100" cy="419100"/>
+            </a:xfrm>
+            <a:prstGeom prst="ellipse">
+              <a:avLst/>
+            </a:prstGeom>
+            <a:solidFill>
+              <a:srgbClr val="F5F5F5"/>
+            </a:solidFill>
+            <a:ln>
+              <a:noFill/>
+            </a:ln>
+            <a:effectLst>
+              <a:outerShdw blurRad="76200" dist="19050" dir="5400000" algn="ctr" rotWithShape="0">
+                <a:srgbClr val="000000">
+                  <a:alpha val="5250"/>
+                </a:srgbClr>
+              </a:outerShdw>
+            </a:effectLst>
+          </p:spPr>
+        </p:sp>
+        <p:sp>
+          <p:nvSpPr>
+            <p:cNvPr id="78" name="Freeform 78"/>
+            <p:cNvSpPr/>
+            <p:nvPr/>
+          </p:nvSpPr>
+          <p:spPr>
+            <a:xfrm>
+              <a:off x="6396487" y="3867150"/>
+              <a:ext cx="199117" cy="190602"/>
+            </a:xfrm>
+            <a:custGeom>
+              <a:avLst/>
+              <a:gdLst/>
+              <a:ahLst/>
+              <a:cxnLst/>
+              <a:rect l="l" t="t" r="r" b="b"/>
+              <a:pathLst>
+                <a:path w="199117" h="190602">
+                  <a:moveTo>
+                    <a:pt x="99544" y="0"/>
+                  </a:moveTo>
+                  <a:lnTo>
+                    <a:pt x="100668" y="67"/>
+                  </a:lnTo>
+                  <a:lnTo>
+                    <a:pt x="101230" y="143"/>
+                  </a:lnTo>
+                  <a:lnTo>
+                    <a:pt x="101811" y="267"/>
+                  </a:lnTo>
+                  <a:lnTo>
+                    <a:pt x="102868" y="591"/>
+                  </a:lnTo>
+                  <a:cubicBezTo>
+                    <a:pt x="103598" y="860"/>
+                    <a:pt x="104293" y="1218"/>
+                    <a:pt x="104935" y="1657"/>
+                  </a:cubicBezTo>
+                  <a:lnTo>
+                    <a:pt x="105926" y="2438"/>
+                  </a:lnTo>
+                  <a:lnTo>
+                    <a:pt x="108354" y="4515"/>
+                  </a:lnTo>
+                  <a:cubicBezTo>
+                    <a:pt x="127569" y="20475"/>
+                    <a:pt x="151854" y="29045"/>
+                    <a:pt x="176830" y="28680"/>
+                  </a:cubicBezTo>
+                  <a:lnTo>
+                    <a:pt x="180087" y="28585"/>
+                  </a:lnTo>
+                  <a:cubicBezTo>
+                    <a:pt x="184470" y="28385"/>
+                    <a:pt x="188423" y="31204"/>
+                    <a:pt x="189660" y="35414"/>
+                  </a:cubicBezTo>
+                  <a:cubicBezTo>
+                    <a:pt x="199117" y="67583"/>
+                    <a:pt x="195123" y="102211"/>
+                    <a:pt x="178593" y="131383"/>
+                  </a:cubicBezTo>
+                  <a:cubicBezTo>
+                    <a:pt x="162063" y="160555"/>
+                    <a:pt x="134409" y="181776"/>
+                    <a:pt x="101954" y="190195"/>
+                  </a:cubicBezTo>
+                  <a:cubicBezTo>
+                    <a:pt x="100386" y="190602"/>
+                    <a:pt x="98740" y="190602"/>
+                    <a:pt x="97172" y="190195"/>
+                  </a:cubicBezTo>
+                  <a:cubicBezTo>
+                    <a:pt x="64715" y="181778"/>
+                    <a:pt x="37059" y="160558"/>
+                    <a:pt x="20527" y="131386"/>
+                  </a:cubicBezTo>
+                  <a:cubicBezTo>
+                    <a:pt x="3994" y="102213"/>
+                    <a:pt x="0" y="67584"/>
+                    <a:pt x="9456" y="35414"/>
+                  </a:cubicBezTo>
+                  <a:cubicBezTo>
+                    <a:pt x="10693" y="31204"/>
+                    <a:pt x="14646" y="28385"/>
+                    <a:pt x="19029" y="28585"/>
+                  </a:cubicBezTo>
+                  <a:cubicBezTo>
+                    <a:pt x="45103" y="29776"/>
+                    <a:pt x="70684" y="21193"/>
+                    <a:pt x="90762" y="4515"/>
+                  </a:cubicBezTo>
+                  <a:lnTo>
+                    <a:pt x="93267" y="2372"/>
+                  </a:lnTo>
+                  <a:lnTo>
+                    <a:pt x="94181" y="1657"/>
+                  </a:lnTo>
+                  <a:cubicBezTo>
+                    <a:pt x="94824" y="1218"/>
+                    <a:pt x="95518" y="860"/>
+                    <a:pt x="96248" y="591"/>
+                  </a:cubicBezTo>
+                  <a:lnTo>
+                    <a:pt x="97315" y="267"/>
+                  </a:lnTo>
+                  <a:cubicBezTo>
+                    <a:pt x="97688" y="177"/>
+                    <a:pt x="98067" y="110"/>
+                    <a:pt x="98448" y="67"/>
+                  </a:cubicBezTo>
+                  <a:lnTo>
+                    <a:pt x="99544" y="0"/>
+                  </a:lnTo>
+                  <a:close/>
+                  <a:moveTo>
+                    <a:pt x="134882" y="69466"/>
+                  </a:moveTo>
+                  <a:cubicBezTo>
+                    <a:pt x="133095" y="67677"/>
+                    <a:pt x="130671" y="66672"/>
+                    <a:pt x="128143" y="66672"/>
+                  </a:cubicBezTo>
+                  <a:cubicBezTo>
+                    <a:pt x="125615" y="66672"/>
+                    <a:pt x="123190" y="67677"/>
+                    <a:pt x="121404" y="69466"/>
+                  </a:cubicBezTo>
+                  <a:lnTo>
+                    <a:pt x="90038" y="100822"/>
+                  </a:lnTo>
+                  <a:lnTo>
+                    <a:pt x="77722" y="88516"/>
+                  </a:lnTo>
+                  <a:lnTo>
+                    <a:pt x="76827" y="87725"/>
+                  </a:lnTo>
+                  <a:cubicBezTo>
+                    <a:pt x="72854" y="84653"/>
+                    <a:pt x="67178" y="85194"/>
+                    <a:pt x="63856" y="88961"/>
+                  </a:cubicBezTo>
+                  <a:cubicBezTo>
+                    <a:pt x="60534" y="92728"/>
+                    <a:pt x="60708" y="98427"/>
+                    <a:pt x="64254" y="101984"/>
+                  </a:cubicBezTo>
+                  <a:lnTo>
+                    <a:pt x="83304" y="121034"/>
+                  </a:lnTo>
+                  <a:lnTo>
+                    <a:pt x="84199" y="121825"/>
+                  </a:lnTo>
+                  <a:cubicBezTo>
+                    <a:pt x="87991" y="124766"/>
+                    <a:pt x="93379" y="124427"/>
+                    <a:pt x="96772" y="121034"/>
+                  </a:cubicBezTo>
+                  <a:lnTo>
+                    <a:pt x="134872" y="82934"/>
+                  </a:lnTo>
+                  <a:lnTo>
+                    <a:pt x="135663" y="82039"/>
+                  </a:lnTo>
+                  <a:cubicBezTo>
+                    <a:pt x="138604" y="78247"/>
+                    <a:pt x="138265" y="72859"/>
+                    <a:pt x="134872" y="69466"/>
+                  </a:cubicBezTo>
+                  <a:close/>
+                </a:path>
+              </a:pathLst>
+            </a:custGeom>
+            <a:solidFill>
+              <a:srgbClr val="888888"/>
+            </a:solidFill>
+            <a:ln>
+              <a:noFill/>
+            </a:ln>
+            <a:effectLst>
+              <a:outerShdw blurRad="76200" dist="19050" dir="5400000" algn="ctr" rotWithShape="0">
+                <a:srgbClr val="000000">
+                  <a:alpha val="5250"/>
+                </a:srgbClr>
+              </a:outerShdw>
+            </a:effectLst>
+          </p:spPr>
+        </p:sp>
+        <p:sp>
+          <p:nvSpPr>
+            <p:cNvPr id="79" name="TextBox 79"/>
+            <p:cNvSpPr txBox="1"/>
+            <p:nvPr/>
+          </p:nvSpPr>
+          <p:spPr>
+            <a:xfrm>
+              <a:off x="6805612" y="3783806"/>
+              <a:ext cx="989445" cy="228600"/>
+            </a:xfrm>
+            <a:prstGeom prst="rect">
+              <a:avLst/>
+            </a:prstGeom>
+            <a:noFill/>
+            <a:ln>
+              <a:noFill/>
+            </a:ln>
+            <a:effectLst>
+              <a:outerShdw blurRad="76200" dist="19050" dir="5400000" algn="ctr" rotWithShape="0">
+                <a:srgbClr val="000000">
+                  <a:alpha val="5250"/>
+                </a:srgbClr>
+              </a:outerShdw>
+            </a:effectLst>
+          </p:spPr>
+          <p:txBody>
+            <a:bodyPr wrap="none" lIns="0" tIns="0" rIns="0" bIns="0" anchor="t" anchorCtr="0">
+              <a:spAutoFit/>
+            </a:bodyPr>
+            <a:lstStyle/>
+            <a:p>
+              <a:pPr algn="l"/>
+              <a:r>
+                <a:rPr lang="zh-CN" sz="1125" b="1" dirty="0">
+                  <a:solidFill>
+                    <a:srgbClr val="1A1A1A"/>
+                  </a:solidFill>
+                  <a:latin typeface="Arial"/>
+                  <a:ea typeface="Microsoft YaHei"/>
+                  <a:cs typeface="Arial"/>
+                </a:rPr>
+                <a:t>Nephrologist</a:t>
+              </a:r>
+            </a:p>
+          </p:txBody>
+        </p:sp>
+        <p:sp>
+          <p:nvSpPr>
+            <p:cNvPr id="80" name="TextBox 80"/>
+            <p:cNvSpPr txBox="1"/>
+            <p:nvPr/>
+          </p:nvSpPr>
+          <p:spPr>
+            <a:xfrm>
+              <a:off x="6809422" y="3987641"/>
+              <a:ext cx="4214129" cy="167640"/>
+            </a:xfrm>
+            <a:prstGeom prst="rect">
+              <a:avLst/>
+            </a:prstGeom>
+            <a:noFill/>
+            <a:ln>
+              <a:noFill/>
+            </a:ln>
+            <a:effectLst>
+              <a:outerShdw blurRad="76200" dist="19050" dir="5400000" algn="ctr" rotWithShape="0">
+                <a:srgbClr val="000000">
+                  <a:alpha val="5250"/>
+                </a:srgbClr>
+              </a:outerShdw>
+            </a:effectLst>
+          </p:spPr>
+          <p:txBody>
+            <a:bodyPr wrap="none" lIns="0" tIns="0" rIns="0" bIns="0" anchor="t" anchorCtr="0">
+              <a:spAutoFit/>
+            </a:bodyPr>
+            <a:lstStyle/>
+            <a:p>
+              <a:pPr algn="l"/>
+              <a:r>
+                <a:rPr lang="zh-CN" sz="825" b="1" dirty="0">
+                  <a:solidFill>
+                    <a:srgbClr val="555555"/>
+                  </a:solidFill>
+                  <a:latin typeface="Arial"/>
+                  <a:ea typeface="Microsoft YaHei"/>
+                  <a:cs typeface="Arial"/>
+                </a:rPr>
+                <a:t>Clexane role: Hemodialysis circuit anticoagulation + VTE management in CKD</a:t>
+              </a:r>
+            </a:p>
+          </p:txBody>
+        </p:sp>
+        <p:sp>
+          <p:nvSpPr>
+            <p:cNvPr id="81" name="Line 81"/>
+            <p:cNvSpPr/>
+            <p:nvPr/>
+          </p:nvSpPr>
+          <p:spPr>
+            <a:xfrm>
+              <a:off x="6286500" y="4200525"/>
+              <a:ext cx="5448300" cy="9525"/>
+            </a:xfrm>
+            <a:custGeom>
+              <a:avLst/>
+              <a:gdLst/>
+              <a:ahLst/>
+              <a:cxnLst/>
+              <a:rect l="l" t="t" r="r" b="b"/>
+              <a:pathLst>
+                <a:path w="5448300" h="9525">
+                  <a:moveTo>
+                    <a:pt x="0" y="0"/>
+                  </a:moveTo>
+                  <a:lnTo>
+                    <a:pt x="5448300" y="0"/>
+                  </a:lnTo>
+                </a:path>
+              </a:pathLst>
+            </a:custGeom>
+            <a:noFill/>
+            <a:ln w="9525">
+              <a:solidFill>
+                <a:srgbClr val="F5F5F5"/>
+              </a:solidFill>
+            </a:ln>
+          </p:spPr>
+        </p:sp>
+        <p:sp>
+          <p:nvSpPr>
+            <p:cNvPr id="82" name="TextBox 82"/>
+            <p:cNvSpPr txBox="1"/>
+            <p:nvPr/>
+          </p:nvSpPr>
+          <p:spPr>
+            <a:xfrm>
+              <a:off x="6275070" y="4303395"/>
+              <a:ext cx="848263" cy="182880"/>
+            </a:xfrm>
+            <a:prstGeom prst="rect">
+              <a:avLst/>
+            </a:prstGeom>
+            <a:noFill/>
+            <a:ln>
+              <a:noFill/>
+            </a:ln>
+            <a:effectLst>
+              <a:outerShdw blurRad="76200" dist="19050" dir="5400000" algn="ctr" rotWithShape="0">
+                <a:srgbClr val="000000">
+                  <a:alpha val="5250"/>
+                </a:srgbClr>
+              </a:outerShdw>
+            </a:effectLst>
+          </p:spPr>
+          <p:txBody>
+            <a:bodyPr wrap="none" lIns="0" tIns="0" rIns="0" bIns="0" anchor="t" anchorCtr="0">
+              <a:spAutoFit/>
+            </a:bodyPr>
+            <a:lstStyle/>
+            <a:p>
+              <a:pPr algn="l"/>
+              <a:r>
+                <a:rPr lang="zh-CN" sz="900" b="1" dirty="0">
+                  <a:solidFill>
+                    <a:srgbClr val="555555"/>
+                  </a:solidFill>
+                  <a:latin typeface="Arial"/>
+                  <a:ea typeface="Microsoft YaHei"/>
+                  <a:cs typeface="Arial"/>
+                </a:rPr>
+                <a:t>Key message:</a:t>
+              </a:r>
+            </a:p>
+          </p:txBody>
+        </p:sp>
+        <p:sp>
+          <p:nvSpPr>
+            <p:cNvPr id="83" name="TextBox 83"/>
+            <p:cNvSpPr txBox="1"/>
+            <p:nvPr/>
+          </p:nvSpPr>
+          <p:spPr>
+            <a:xfrm>
+              <a:off x="6275070" y="4474845"/>
+              <a:ext cx="4205383" cy="182880"/>
+            </a:xfrm>
+            <a:prstGeom prst="rect">
+              <a:avLst/>
+            </a:prstGeom>
+            <a:noFill/>
+            <a:ln>
+              <a:noFill/>
+            </a:ln>
+            <a:effectLst>
+              <a:outerShdw blurRad="76200" dist="19050" dir="5400000" algn="ctr" rotWithShape="0">
+                <a:srgbClr val="000000">
+                  <a:alpha val="5250"/>
+                </a:srgbClr>
+              </a:outerShdw>
+            </a:effectLst>
+          </p:spPr>
+          <p:txBody>
+            <a:bodyPr wrap="none" lIns="0" tIns="0" rIns="0" bIns="0" anchor="t" anchorCtr="0">
+              <a:spAutoFit/>
+            </a:bodyPr>
+            <a:lstStyle/>
+            <a:p>
+              <a:pPr algn="l"/>
+              <a:r>
+                <a:rPr lang="zh-CN" sz="900" dirty="0">
+                  <a:solidFill>
+                    <a:srgbClr val="555555"/>
+                  </a:solidFill>
+                  <a:latin typeface="Arial"/>
+                  <a:ea typeface="Microsoft YaHei"/>
+                  <a:cs typeface="Arial"/>
+                </a:rPr>
+                <a:t>Dose-adjustable in CKD (CrCl ≥ 15 mL/min with monitoring) — established</a:t>
+              </a:r>
+            </a:p>
+          </p:txBody>
+        </p:sp>
+        <p:sp>
+          <p:nvSpPr>
+            <p:cNvPr id="84" name="TextBox 84"/>
+            <p:cNvSpPr txBox="1"/>
+            <p:nvPr/>
+          </p:nvSpPr>
+          <p:spPr>
+            <a:xfrm>
+              <a:off x="6275070" y="4646295"/>
+              <a:ext cx="4277392" cy="182880"/>
+            </a:xfrm>
+            <a:prstGeom prst="rect">
+              <a:avLst/>
+            </a:prstGeom>
+            <a:noFill/>
+            <a:ln>
+              <a:noFill/>
+            </a:ln>
+            <a:effectLst>
+              <a:outerShdw blurRad="76200" dist="19050" dir="5400000" algn="ctr" rotWithShape="0">
+                <a:srgbClr val="000000">
+                  <a:alpha val="5250"/>
+                </a:srgbClr>
+              </a:outerShdw>
+            </a:effectLst>
+          </p:spPr>
+          <p:txBody>
+            <a:bodyPr wrap="none" lIns="0" tIns="0" rIns="0" bIns="0" anchor="t" anchorCtr="0">
+              <a:spAutoFit/>
+            </a:bodyPr>
+            <a:lstStyle/>
+            <a:p>
+              <a:pPr algn="l"/>
+              <a:r>
+                <a:rPr lang="zh-CN" sz="900" dirty="0">
+                  <a:solidFill>
+                    <a:srgbClr val="555555"/>
+                  </a:solidFill>
+                  <a:latin typeface="Arial"/>
+                  <a:ea typeface="Microsoft YaHei"/>
+                  <a:cs typeface="Arial"/>
+                </a:rPr>
+                <a:t>safety profile in renal patients where DOACs are often contraindicated.</a:t>
+              </a:r>
+            </a:p>
+          </p:txBody>
+        </p:sp>
+        <p:sp>
+          <p:nvSpPr>
+            <p:cNvPr id="85" name="TextBox 85"/>
+            <p:cNvSpPr txBox="1"/>
+            <p:nvPr/>
+          </p:nvSpPr>
+          <p:spPr>
+            <a:xfrm>
+              <a:off x="6275070" y="4874895"/>
+              <a:ext cx="4547426" cy="182880"/>
+            </a:xfrm>
+            <a:prstGeom prst="rect">
+              <a:avLst/>
+            </a:prstGeom>
+            <a:noFill/>
+            <a:ln>
+              <a:noFill/>
+            </a:ln>
+            <a:effectLst>
+              <a:outerShdw blurRad="76200" dist="19050" dir="5400000" algn="ctr" rotWithShape="0">
+                <a:srgbClr val="000000">
+                  <a:alpha val="5250"/>
+                </a:srgbClr>
+              </a:outerShdw>
+            </a:effectLst>
+          </p:spPr>
+          <p:txBody>
+            <a:bodyPr wrap="none" lIns="0" tIns="0" rIns="0" bIns="0" anchor="t" anchorCtr="0">
+              <a:spAutoFit/>
+            </a:bodyPr>
+            <a:lstStyle/>
+            <a:p>
+              <a:pPr algn="l"/>
+              <a:r>
+                <a:rPr lang="zh-CN" sz="900" dirty="0">
+                  <a:solidFill>
+                    <a:srgbClr val="555555"/>
+                  </a:solidFill>
+                  <a:latin typeface="Arial"/>
+                  <a:ea typeface="Microsoft YaHei"/>
+                  <a:cs typeface="Arial"/>
+                </a:rPr>
+                <a:t>Hemodialysis use: 1 mg/kg IV bolus at circuit start prevents clotting without</a:t>
+              </a:r>
+            </a:p>
+          </p:txBody>
+        </p:sp>
+        <p:sp>
+          <p:nvSpPr>
+            <p:cNvPr id="86" name="TextBox 86"/>
+            <p:cNvSpPr txBox="1"/>
+            <p:nvPr/>
+          </p:nvSpPr>
+          <p:spPr>
+            <a:xfrm>
+              <a:off x="6275070" y="5046345"/>
+              <a:ext cx="4511421" cy="182880"/>
+            </a:xfrm>
+            <a:prstGeom prst="rect">
+              <a:avLst/>
+            </a:prstGeom>
+            <a:noFill/>
+            <a:ln>
+              <a:noFill/>
+            </a:ln>
+            <a:effectLst>
+              <a:outerShdw blurRad="76200" dist="19050" dir="5400000" algn="ctr" rotWithShape="0">
+                <a:srgbClr val="000000">
+                  <a:alpha val="5250"/>
+                </a:srgbClr>
+              </a:outerShdw>
+            </a:effectLst>
+          </p:spPr>
+          <p:txBody>
+            <a:bodyPr wrap="none" lIns="0" tIns="0" rIns="0" bIns="0" anchor="t" anchorCtr="0">
+              <a:spAutoFit/>
+            </a:bodyPr>
+            <a:lstStyle/>
+            <a:p>
+              <a:pPr algn="l"/>
+              <a:r>
+                <a:rPr lang="zh-CN" sz="900" dirty="0">
+                  <a:solidFill>
+                    <a:srgbClr val="555555"/>
+                  </a:solidFill>
+                  <a:latin typeface="Arial"/>
+                  <a:ea typeface="Microsoft YaHei"/>
+                  <a:cs typeface="Arial"/>
+                </a:rPr>
+                <a:t>need for continuous heparin infusion — simpler workflow for dialysis nurses.</a:t>
+              </a:r>
+            </a:p>
+          </p:txBody>
+        </p:sp>
+        <p:sp>
+          <p:nvSpPr>
+            <p:cNvPr id="87" name="Rectangle 87"/>
+            <p:cNvSpPr/>
+            <p:nvPr/>
+          </p:nvSpPr>
+          <p:spPr>
+            <a:xfrm>
+              <a:off x="6286500" y="5314950"/>
+              <a:ext cx="5410200" cy="476250"/>
+            </a:xfrm>
+            <a:prstGeom prst="roundRect">
+              <a:avLst>
+                <a:gd name="adj" fmla="val 12000"/>
+              </a:avLst>
+            </a:prstGeom>
+            <a:solidFill>
+              <a:srgbClr val="F5F5F5"/>
+            </a:solidFill>
+            <a:ln>
+              <a:noFill/>
+            </a:ln>
+            <a:effectLst>
+              <a:outerShdw blurRad="76200" dist="19050" dir="5400000" algn="ctr" rotWithShape="0">
+                <a:srgbClr val="000000">
+                  <a:alpha val="5250"/>
+                </a:srgbClr>
+              </a:outerShdw>
+            </a:effectLst>
+          </p:spPr>
+        </p:sp>
+        <p:sp>
+          <p:nvSpPr>
+            <p:cNvPr id="88" name="TextBox 88"/>
+            <p:cNvSpPr txBox="1"/>
+            <p:nvPr/>
+          </p:nvSpPr>
+          <p:spPr>
+            <a:xfrm>
+              <a:off x="7732614" y="5398770"/>
+              <a:ext cx="2517972" cy="182880"/>
+            </a:xfrm>
+            <a:prstGeom prst="rect">
+              <a:avLst/>
+            </a:prstGeom>
+            <a:noFill/>
+            <a:ln>
+              <a:noFill/>
+            </a:ln>
+            <a:effectLst>
+              <a:outerShdw blurRad="76200" dist="19050" dir="5400000" algn="ctr" rotWithShape="0">
+                <a:srgbClr val="000000">
+                  <a:alpha val="5250"/>
+                </a:srgbClr>
+              </a:outerShdw>
+            </a:effectLst>
+          </p:spPr>
+          <p:txBody>
+            <a:bodyPr wrap="none" lIns="0" tIns="0" rIns="0" bIns="0" anchor="t" anchorCtr="0">
+              <a:spAutoFit/>
+            </a:bodyPr>
+            <a:lstStyle/>
+            <a:p>
+              <a:pPr algn="ctr"/>
+              <a:r>
+                <a:rPr lang="zh-CN" sz="900" b="1" dirty="0">
+                  <a:solidFill>
+                    <a:srgbClr val="555555"/>
+                  </a:solidFill>
+                  <a:latin typeface="Arial"/>
+                  <a:ea typeface="Microsoft YaHei"/>
+                  <a:cs typeface="Arial"/>
+                </a:rPr>
+                <a:t>Handling the renal objection proactively:</a:t>
+              </a:r>
+            </a:p>
+          </p:txBody>
+        </p:sp>
+        <p:sp>
+          <p:nvSpPr>
+            <p:cNvPr id="89" name="TextBox 89"/>
+            <p:cNvSpPr txBox="1"/>
+            <p:nvPr/>
+          </p:nvSpPr>
+          <p:spPr>
+            <a:xfrm>
+              <a:off x="7075134" y="5578316"/>
+              <a:ext cx="3832931" cy="167640"/>
+            </a:xfrm>
+            <a:prstGeom prst="rect">
+              <a:avLst/>
+            </a:prstGeom>
+            <a:noFill/>
+            <a:ln>
+              <a:noFill/>
+            </a:ln>
+            <a:effectLst>
+              <a:outerShdw blurRad="76200" dist="19050" dir="5400000" algn="ctr" rotWithShape="0">
+                <a:srgbClr val="000000">
+                  <a:alpha val="5250"/>
+                </a:srgbClr>
+              </a:outerShdw>
+            </a:effectLst>
+          </p:spPr>
+          <p:txBody>
+            <a:bodyPr wrap="none" lIns="0" tIns="0" rIns="0" bIns="0" anchor="t" anchorCtr="0">
+              <a:spAutoFit/>
+            </a:bodyPr>
+            <a:lstStyle/>
+            <a:p>
+              <a:pPr algn="ctr"/>
+              <a:r>
+                <a:rPr lang="zh-CN" sz="825" dirty="0">
+                  <a:solidFill>
+                    <a:srgbClr val="888888"/>
+                  </a:solidFill>
+                  <a:latin typeface="Arial"/>
+                  <a:ea typeface="Microsoft YaHei"/>
+                  <a:cs typeface="Arial"/>
+                </a:rPr>
+                <a:t>"Dose-adjust at CrCl 15–30; avoid or use anti-Xa monitoring below 15."</a:t>
+              </a:r>
+            </a:p>
+          </p:txBody>
+        </p:sp>
+      </p:grpSp>
+      <p:sp>
+        <p:nvSpPr>
+          <p:cNvPr id="91" name="Rectangle 91"/>
+          <p:cNvSpPr/>
+          <p:nvPr/>
+        </p:nvSpPr>
+        <p:spPr>
+          <a:xfrm>
+            <a:off x="342900" y="6019800"/>
+            <a:ext cx="11506200" cy="400050"/>
+          </a:xfrm>
+          <a:prstGeom prst="roundRect">
+            <a:avLst>
+              <a:gd name="adj" fmla="val 14286"/>
+            </a:avLst>
+          </a:prstGeom>
+          <a:solidFill>
+            <a:srgbClr val="AE232F"/>
+          </a:solidFill>
+          <a:ln>
+            <a:noFill/>
+          </a:ln>
+          <a:effectLst>
+            <a:outerShdw blurRad="76200" dist="19050" dir="5400000" algn="ctr" rotWithShape="0">
+              <a:srgbClr val="000000">
+                <a:alpha val="5250"/>
+              </a:srgbClr>
+            </a:outerShdw>
+          </a:effectLst>
+        </p:spPr>
+      </p:sp>
+      <p:sp>
+        <p:nvSpPr>
+          <p:cNvPr id="92" name="Freeform 92"/>
+          <p:cNvSpPr/>
+          <p:nvPr/>
+        </p:nvSpPr>
+        <p:spPr>
+          <a:xfrm>
+            <a:off x="521875" y="6132529"/>
+            <a:ext cx="175364" cy="167135"/>
+          </a:xfrm>
+          <a:custGeom>
+            <a:avLst/>
+            <a:gdLst/>
+            <a:ahLst/>
+            <a:cxnLst/>
+            <a:rect l="l" t="t" r="r" b="b"/>
+            <a:pathLst>
+              <a:path w="175364" h="167135">
+                <a:moveTo>
+                  <a:pt x="57904" y="50308"/>
+                </a:moveTo>
+                <a:lnTo>
+                  <a:pt x="7263" y="57650"/>
+                </a:lnTo>
+                <a:lnTo>
+                  <a:pt x="6366" y="57832"/>
+                </a:lnTo>
+                <a:cubicBezTo>
+                  <a:pt x="3602" y="58566"/>
+                  <a:pt x="1446" y="60730"/>
+                  <a:pt x="723" y="63498"/>
+                </a:cubicBezTo>
+                <a:cubicBezTo>
+                  <a:pt x="0" y="66265"/>
+                  <a:pt x="822" y="69207"/>
+                  <a:pt x="2874" y="71199"/>
+                </a:cubicBezTo>
+                <a:lnTo>
+                  <a:pt x="39561" y="106910"/>
+                </a:lnTo>
+                <a:lnTo>
+                  <a:pt x="30909" y="157353"/>
+                </a:lnTo>
+                <a:lnTo>
+                  <a:pt x="30806" y="158226"/>
+                </a:lnTo>
+                <a:cubicBezTo>
+                  <a:pt x="30636" y="161085"/>
+                  <a:pt x="32021" y="163814"/>
+                  <a:pt x="34428" y="165366"/>
+                </a:cubicBezTo>
+                <a:cubicBezTo>
+                  <a:pt x="36835" y="166918"/>
+                  <a:pt x="39892" y="167053"/>
+                  <a:pt x="42426" y="165719"/>
+                </a:cubicBezTo>
+                <a:lnTo>
+                  <a:pt x="87718" y="141906"/>
+                </a:lnTo>
+                <a:lnTo>
+                  <a:pt x="132906" y="165719"/>
+                </a:lnTo>
+                <a:lnTo>
+                  <a:pt x="133699" y="166084"/>
+                </a:lnTo>
+                <a:cubicBezTo>
+                  <a:pt x="136367" y="167135"/>
+                  <a:pt x="139394" y="166665"/>
+                  <a:pt x="141618" y="164856"/>
+                </a:cubicBezTo>
+                <a:cubicBezTo>
+                  <a:pt x="143842" y="163046"/>
+                  <a:pt x="144917" y="160178"/>
+                  <a:pt x="144431" y="157353"/>
+                </a:cubicBezTo>
+                <a:lnTo>
+                  <a:pt x="135771" y="106910"/>
+                </a:lnTo>
+                <a:lnTo>
+                  <a:pt x="172474" y="71191"/>
+                </a:lnTo>
+                <a:lnTo>
+                  <a:pt x="173093" y="70517"/>
+                </a:lnTo>
+                <a:cubicBezTo>
+                  <a:pt x="174894" y="68299"/>
+                  <a:pt x="175364" y="65285"/>
+                  <a:pt x="174324" y="62624"/>
+                </a:cubicBezTo>
+                <a:cubicBezTo>
+                  <a:pt x="173285" y="59964"/>
+                  <a:pt x="170896" y="58067"/>
+                  <a:pt x="168069" y="57658"/>
+                </a:cubicBezTo>
+                <a:lnTo>
+                  <a:pt x="117428" y="50308"/>
+                </a:lnTo>
+                <a:lnTo>
+                  <a:pt x="94790" y="4429"/>
+                </a:lnTo>
+                <a:cubicBezTo>
+                  <a:pt x="93454" y="1717"/>
+                  <a:pt x="90693" y="0"/>
+                  <a:pt x="87670" y="0"/>
+                </a:cubicBezTo>
+                <a:cubicBezTo>
+                  <a:pt x="84647" y="0"/>
+                  <a:pt x="81886" y="1717"/>
+                  <a:pt x="80550" y="4429"/>
+                </a:cubicBezTo>
+                <a:lnTo>
+                  <a:pt x="57904" y="50308"/>
+                </a:lnTo>
+                <a:close/>
+              </a:path>
+            </a:pathLst>
+          </a:custGeom>
+          <a:solidFill>
+            <a:srgbClr val="FFFFFF"/>
+          </a:solidFill>
+          <a:ln>
+            <a:noFill/>
+          </a:ln>
+        </p:spPr>
+      </p:sp>
+      <p:sp>
+        <p:nvSpPr>
+          <p:cNvPr id="93" name="TextBox 93"/>
+          <p:cNvSpPr txBox="1"/>
+          <p:nvPr/>
+        </p:nvSpPr>
+        <p:spPr>
+          <a:xfrm>
+            <a:off x="788670" y="6094095"/>
+            <a:ext cx="482817" cy="182880"/>
+          </a:xfrm>
+          <a:prstGeom prst="rect">
+            <a:avLst/>
+          </a:prstGeom>
+          <a:noFill/>
+          <a:ln>
+            <a:noFill/>
+          </a:ln>
+        </p:spPr>
+        <p:txBody>
+          <a:bodyPr wrap="none" lIns="0" tIns="0" rIns="0" bIns="0" anchor="t" anchorCtr="0">
+            <a:spAutoFit/>
+          </a:bodyPr>
+          <a:lstStyle/>
+          <a:p>
+            <a:pPr algn="l"/>
+            <a:r>
+              <a:rPr lang="zh-CN" sz="900" b="1" dirty="0">
+                <a:solidFill>
+                  <a:srgbClr val="FFFFFF"/>
+                </a:solidFill>
+                <a:latin typeface="Arial"/>
+                <a:ea typeface="Microsoft YaHei"/>
+                <a:cs typeface="Arial"/>
+              </a:rPr>
+              <a:t>Tier A =</a:t>
+            </a:r>
+          </a:p>
+        </p:txBody>
+      </p:sp>
+      <p:sp>
+        <p:nvSpPr>
+          <p:cNvPr id="94" name="TextBox 94"/>
+          <p:cNvSpPr txBox="1"/>
+          <p:nvPr/>
+        </p:nvSpPr>
+        <p:spPr>
+          <a:xfrm>
+            <a:off x="1283970" y="6094095"/>
+            <a:ext cx="4991481" cy="182880"/>
+          </a:xfrm>
+          <a:prstGeom prst="rect">
+            <a:avLst/>
+          </a:prstGeom>
+          <a:noFill/>
+          <a:ln>
+            <a:noFill/>
+          </a:ln>
+        </p:spPr>
+        <p:txBody>
+          <a:bodyPr wrap="none" lIns="0" tIns="0" rIns="0" bIns="0" anchor="t" anchorCtr="0">
+            <a:spAutoFit/>
+          </a:bodyPr>
+          <a:lstStyle/>
+          <a:p>
+            <a:pPr algn="l"/>
+            <a:r>
+              <a:rPr lang="zh-CN" sz="900" dirty="0">
+                <a:solidFill>
+                  <a:srgbClr val="F9E5E7"/>
+                </a:solidFill>
+                <a:latin typeface="Arial"/>
+                <a:ea typeface="Microsoft YaHei"/>
+                <a:cs typeface="Arial"/>
+              </a:rPr>
+              <a:t>High prescribing volume + strong Clexane fit → priority call frequency (2× per week).</a:t>
+            </a:r>
+          </a:p>
+        </p:txBody>
+      </p:sp>
+      <p:sp>
+        <p:nvSpPr>
+          <p:cNvPr id="95" name="TextBox 95"/>
+          <p:cNvSpPr txBox="1"/>
+          <p:nvPr/>
+        </p:nvSpPr>
+        <p:spPr>
+          <a:xfrm>
+            <a:off x="7227570" y="6094095"/>
+            <a:ext cx="1049888" cy="182880"/>
+          </a:xfrm>
+          <a:prstGeom prst="rect">
+            <a:avLst/>
+          </a:prstGeom>
+          <a:noFill/>
+          <a:ln>
+            <a:noFill/>
+          </a:ln>
+        </p:spPr>
+        <p:txBody>
+          <a:bodyPr wrap="none" lIns="0" tIns="0" rIns="0" bIns="0" anchor="t" anchorCtr="0">
+            <a:spAutoFit/>
+          </a:bodyPr>
+          <a:lstStyle/>
+          <a:p>
+            <a:pPr algn="l"/>
+            <a:r>
+              <a:rPr lang="zh-CN" sz="900" b="1" dirty="0">
+                <a:solidFill>
+                  <a:srgbClr val="FFFFFF"/>
+                </a:solidFill>
+                <a:latin typeface="Arial"/>
+                <a:ea typeface="Microsoft YaHei"/>
+                <a:cs typeface="Arial"/>
+              </a:rPr>
+              <a:t>Ward Pharmacist</a:t>
+            </a:r>
+          </a:p>
+        </p:txBody>
+      </p:sp>
+      <p:sp>
+        <p:nvSpPr>
+          <p:cNvPr id="96" name="TextBox 96"/>
+          <p:cNvSpPr txBox="1"/>
+          <p:nvPr/>
+        </p:nvSpPr>
+        <p:spPr>
+          <a:xfrm>
+            <a:off x="8275320" y="6094095"/>
+            <a:ext cx="4745450" cy="182880"/>
+          </a:xfrm>
+          <a:prstGeom prst="rect">
+            <a:avLst/>
+          </a:prstGeom>
+          <a:noFill/>
+          <a:ln>
+            <a:noFill/>
+          </a:ln>
+        </p:spPr>
+        <p:txBody>
+          <a:bodyPr wrap="none" lIns="0" tIns="0" rIns="0" bIns="0" anchor="t" anchorCtr="0">
+            <a:spAutoFit/>
+          </a:bodyPr>
+          <a:lstStyle/>
+          <a:p>
+            <a:pPr algn="l"/>
+            <a:r>
+              <a:rPr lang="zh-CN" sz="900" dirty="0">
+                <a:solidFill>
+                  <a:srgbClr val="F9E5E7"/>
+                </a:solidFill>
+                <a:latin typeface="Arial"/>
+                <a:ea typeface="Microsoft YaHei"/>
+                <a:cs typeface="Arial"/>
+              </a:rPr>
+              <a:t>is a clinical partner, not just a gatekeeper — always engage both MD and PharmD.</a:t>
+            </a:r>
+          </a:p>
+        </p:txBody>
+      </p:sp>
+      <p:sp>
+        <p:nvSpPr>
+          <p:cNvPr id="97" name="TextBox 97"/>
+          <p:cNvSpPr txBox="1"/>
+          <p:nvPr/>
+        </p:nvSpPr>
+        <p:spPr>
+          <a:xfrm>
+            <a:off x="789622" y="6254591"/>
+            <a:ext cx="8668036" cy="167640"/>
+          </a:xfrm>
+          <a:prstGeom prst="rect">
+            <a:avLst/>
+          </a:prstGeom>
+          <a:noFill/>
+          <a:ln>
+            <a:noFill/>
+          </a:ln>
+        </p:spPr>
+        <p:txBody>
+          <a:bodyPr wrap="none" lIns="0" tIns="0" rIns="0" bIns="0" anchor="t" anchorCtr="0">
+            <a:spAutoFit/>
+          </a:bodyPr>
+          <a:lstStyle/>
+          <a:p>
+            <a:pPr algn="l"/>
+            <a:r>
+              <a:rPr lang="zh-CN" sz="825" dirty="0">
+                <a:solidFill>
+                  <a:srgbClr val="F9E5E7"/>
+                </a:solidFill>
+                <a:latin typeface="Arial"/>
+                <a:ea typeface="Microsoft YaHei"/>
+                <a:cs typeface="Arial"/>
+              </a:rPr>
+              <a:t>Tier B = Build relationship in first 60 days, convert to active accounts by Q2. My Pharm.D. background gives me a peer advantage with pharmacist stakeholders.</a:t>
+            </a:r>
+          </a:p>
+        </p:txBody>
+      </p:sp>
+      <p:grpSp>
+        <p:nvGrpSpPr>
+          <p:cNvPr id="100" name="Group 100"/>
+          <p:cNvGrpSpPr/>
+          <p:nvPr/>
+        </p:nvGrpSpPr>
+        <p:grpSpPr>
+          <a:xfrm>
+            <a:off x="0" y="6496050"/>
+            <a:ext cx="12192000" cy="361950"/>
+            <a:chOff x="0" y="6496050"/>
+            <a:chExt cx="12192000" cy="361950"/>
+          </a:xfrm>
+        </p:grpSpPr>
+        <p:sp>
+          <p:nvSpPr>
+            <p:cNvPr id="98" name="Rectangle 98"/>
+            <p:cNvSpPr/>
+            <p:nvPr/>
+          </p:nvSpPr>
+          <p:spPr>
+            <a:xfrm>
+              <a:off x="0" y="6496050"/>
+              <a:ext cx="12192000" cy="361950"/>
+            </a:xfrm>
+            <a:prstGeom prst="rect">
+              <a:avLst/>
+            </a:prstGeom>
+            <a:solidFill>
+              <a:srgbClr val="AE232F"/>
+            </a:solidFill>
+            <a:ln>
+              <a:noFill/>
+            </a:ln>
+          </p:spPr>
+        </p:sp>
+        <p:sp>
+          <p:nvSpPr>
+            <p:cNvPr id="99" name="TextBox 99"/>
+            <p:cNvSpPr txBox="1"/>
+            <p:nvPr/>
+          </p:nvSpPr>
+          <p:spPr>
+            <a:xfrm>
+              <a:off x="4128325" y="6627495"/>
+              <a:ext cx="3935349" cy="182880"/>
+            </a:xfrm>
+            <a:prstGeom prst="rect">
+              <a:avLst/>
+            </a:prstGeom>
+            <a:noFill/>
+            <a:ln>
+              <a:noFill/>
+            </a:ln>
+          </p:spPr>
+          <p:txBody>
+            <a:bodyPr wrap="none" lIns="0" tIns="0" rIns="0" bIns="0" anchor="t" anchorCtr="0">
+              <a:spAutoFit/>
+            </a:bodyPr>
+            <a:lstStyle/>
+            <a:p>
+              <a:pPr algn="ctr"/>
+              <a:r>
+                <a:rPr lang="zh-CN" sz="900" dirty="0">
+                  <a:solidFill>
+                    <a:srgbClr val="FFFFFF"/>
+                  </a:solidFill>
+                  <a:latin typeface="Arial"/>
+                  <a:ea typeface="Microsoft YaHei"/>
+                  <a:cs typeface="Arial"/>
+                </a:rPr>
+                <a:t>Rattanakorn Rattanaroj | Rattanaroj.jan@gmail.com | 080-045-0821</a:t>
+              </a:r>
+            </a:p>
+          </p:txBody>
+        </p:sp>
+      </p:grpSp>
+    </p:spTree>
+  </p:cSld>
+  <p:clrMapOvr>
+    <a:masterClrMapping/>
+  </p:clrMapOvr>
+  <p:transition xmlns:p14="http://schemas.microsoft.com/office/powerpoint/2010/main" p14:dur="400">
+    <p:fade/>
+  </p:transition>
+  <p:timing>
+    <p:tnLst>
+      <p:par>
+        <p:cTn id="1" dur="indefinite" restart="never" nodeType="tmRoot">
+          <p:childTnLst>
+            <p:seq concurrent="1" nextAc="seek">
+              <p:cTn id="2" dur="indefinite" nodeType="mainSeq">
+                <p:childTnLst>
+                  <p:par>
+                    <p:cTn id="3" fill="hold">
+                      <p:stCondLst>
+                        <p:cond delay="indefinite"/>
+                        <p:cond evt="onBegin" delay="0">
+                          <p:tn val="2"/>
+                        </p:cond>
+                      </p:stCondLst>
+                      <p:childTnLst>
+                        <p:par>
+                          <p:cTn id="4" fill="hold">
+                            <p:stCondLst>
+                              <p:cond delay="0"/>
+                            </p:stCondLst>
+                            <p:childTnLst>
+                              <p:par>
+                                <p:cTn id="5" presetID="2" presetClass="entr" presetSubtype="4" fill="hold" nodeType="afterEffect">
+                                  <p:stCondLst>
+                                    <p:cond delay="0"/>
+                                  </p:stCondLst>
+                                  <p:childTnLst>
+                                    <p:set>
+                                      <p:cBhvr>
+                                        <p:cTn id="6" dur="1" fill="hold">
+                                          <p:stCondLst>
+                                            <p:cond delay="0"/>
+                                          </p:stCondLst>
+                                        </p:cTn>
+                                        <p:tgtEl>
+                                          <p:spTgt spid="22"/>
+                                        </p:tgtEl>
+                                        <p:attrNameLst>
+                                          <p:attrName>style.visibility</p:attrName>
+                                        </p:attrNameLst>
+                                      </p:cBhvr>
+                                      <p:to>
+                                        <p:strVal val="visible"/>
+                                      </p:to>
+                                    </p:set>
+                                    <p:animEffect transition="in" filter="slide(fromBottom)">
+                                      <p:cBhvr>
+                                        <p:cTn id="7" dur="400"/>
+                                        <p:tgtEl>
+                                          <p:spTgt spid="22"/>
+                                        </p:tgtEl>
+                                      </p:cBhvr>
+                                    </p:animEffect>
+                                  </p:childTnLst>
+                                </p:cTn>
+                              </p:par>
+                            </p:childTnLst>
+                          </p:cTn>
+                        </p:par>
+                        <p:par>
+                          <p:cTn id="8" fill="hold">
+                            <p:stCondLst>
+                              <p:cond delay="900"/>
+                            </p:stCondLst>
+                            <p:childTnLst>
+                              <p:par>
+                                <p:cTn id="9" presetID="2" presetClass="entr" presetSubtype="4" fill="hold" nodeType="afterEffect">
+                                  <p:stCondLst>
+                                    <p:cond delay="0"/>
+                                  </p:stCondLst>
+                                  <p:childTnLst>
+                                    <p:set>
+                                      <p:cBhvr>
+                                        <p:cTn id="10" dur="1" fill="hold">
+                                          <p:stCondLst>
+                                            <p:cond delay="0"/>
+                                          </p:stCondLst>
+                                        </p:cTn>
+                                        <p:tgtEl>
+                                          <p:spTgt spid="37"/>
+                                        </p:tgtEl>
+                                        <p:attrNameLst>
+                                          <p:attrName>style.visibility</p:attrName>
+                                        </p:attrNameLst>
+                                      </p:cBhvr>
+                                      <p:to>
+                                        <p:strVal val="visible"/>
+                                      </p:to>
+                                    </p:set>
+                                    <p:animEffect transition="in" filter="slide(fromBottom)">
+                                      <p:cBhvr>
+                                        <p:cTn id="11" dur="400"/>
+                                        <p:tgtEl>
+                                          <p:spTgt spid="37"/>
+                                        </p:tgtEl>
+                                      </p:cBhvr>
+                                    </p:animEffect>
+                                  </p:childTnLst>
+                                </p:cTn>
+                              </p:par>
+                            </p:childTnLst>
+                          </p:cTn>
+                        </p:par>
+                        <p:par>
+                          <p:cTn id="12" fill="hold">
+                            <p:stCondLst>
+                              <p:cond delay="1800"/>
+                            </p:stCondLst>
+                            <p:childTnLst>
+                              <p:par>
+                                <p:cTn id="13" presetID="2" presetClass="entr" presetSubtype="4" fill="hold" nodeType="afterEffect">
+                                  <p:stCondLst>
+                                    <p:cond delay="0"/>
+                                  </p:stCondLst>
+                                  <p:childTnLst>
+                                    <p:set>
+                                      <p:cBhvr>
+                                        <p:cTn id="14" dur="1" fill="hold">
+                                          <p:stCondLst>
+                                            <p:cond delay="0"/>
+                                          </p:stCondLst>
+                                        </p:cTn>
+                                        <p:tgtEl>
+                                          <p:spTgt spid="53"/>
+                                        </p:tgtEl>
+                                        <p:attrNameLst>
+                                          <p:attrName>style.visibility</p:attrName>
+                                        </p:attrNameLst>
+                                      </p:cBhvr>
+                                      <p:to>
+                                        <p:strVal val="visible"/>
+                                      </p:to>
+                                    </p:set>
+                                    <p:animEffect transition="in" filter="slide(fromBottom)">
+                                      <p:cBhvr>
+                                        <p:cTn id="15" dur="400"/>
+                                        <p:tgtEl>
+                                          <p:spTgt spid="53"/>
+                                        </p:tgtEl>
+                                      </p:cBhvr>
+                                    </p:animEffect>
+                                  </p:childTnLst>
+                                </p:cTn>
+                              </p:par>
+                            </p:childTnLst>
+                          </p:cTn>
+                        </p:par>
+                        <p:par>
+                          <p:cTn id="16" fill="hold">
+                            <p:stCondLst>
+                              <p:cond delay="2700"/>
+                            </p:stCondLst>
+                            <p:childTnLst>
+                              <p:par>
+                                <p:cTn id="17" presetID="2" presetClass="entr" presetSubtype="4" fill="hold" nodeType="afterEffect">
+                                  <p:stCondLst>
+                                    <p:cond delay="0"/>
+                                  </p:stCondLst>
+                                  <p:childTnLst>
+                                    <p:set>
+                                      <p:cBhvr>
+                                        <p:cTn id="18" dur="1" fill="hold">
+                                          <p:stCondLst>
+                                            <p:cond delay="0"/>
+                                          </p:stCondLst>
+                                        </p:cTn>
+                                        <p:tgtEl>
+                                          <p:spTgt spid="72"/>
+                                        </p:tgtEl>
+                                        <p:attrNameLst>
+                                          <p:attrName>style.visibility</p:attrName>
+                                        </p:attrNameLst>
+                                      </p:cBhvr>
+                                      <p:to>
+                                        <p:strVal val="visible"/>
+                                      </p:to>
+                                    </p:set>
+                                    <p:animEffect transition="in" filter="slide(fromBottom)">
+                                      <p:cBhvr>
+                                        <p:cTn id="19" dur="400"/>
+                                        <p:tgtEl>
+                                          <p:spTgt spid="72"/>
+                                        </p:tgtEl>
+                                      </p:cBhvr>
+                                    </p:animEffect>
+                                  </p:childTnLst>
+                                </p:cTn>
+                              </p:par>
+                            </p:childTnLst>
+                          </p:cTn>
+                        </p:par>
+                        <p:par>
+                          <p:cTn id="20" fill="hold">
+                            <p:stCondLst>
+                              <p:cond delay="3600"/>
+                            </p:stCondLst>
+                            <p:childTnLst>
+                              <p:par>
+                                <p:cTn id="21" presetID="2" presetClass="entr" presetSubtype="4" fill="hold" nodeType="afterEffect">
+                                  <p:stCondLst>
+                                    <p:cond delay="0"/>
+                                  </p:stCondLst>
+                                  <p:childTnLst>
+                                    <p:set>
+                                      <p:cBhvr>
+                                        <p:cTn id="22" dur="1" fill="hold">
+                                          <p:stCondLst>
+                                            <p:cond delay="0"/>
+                                          </p:stCondLst>
+                                        </p:cTn>
+                                        <p:tgtEl>
+                                          <p:spTgt spid="90"/>
+                                        </p:tgtEl>
+                                        <p:attrNameLst>
+                                          <p:attrName>style.visibility</p:attrName>
+                                        </p:attrNameLst>
+                                      </p:cBhvr>
+                                      <p:to>
+                                        <p:strVal val="visible"/>
+                                      </p:to>
+                                    </p:set>
+                                    <p:animEffect transition="in" filter="slide(fromBottom)">
+                                      <p:cBhvr>
+                                        <p:cTn id="23" dur="400"/>
+                                        <p:tgtEl>
+                                          <p:spTgt spid="90"/>
+                                        </p:tgtEl>
+                                      </p:cBhvr>
+                                    </p:animEffect>
+                                  </p:childTnLst>
+                                </p:cTn>
+                              </p:par>
+                            </p:childTnLst>
+                          </p:cTn>
+                        </p:par>
+                      </p:childTnLst>
+                    </p:cTn>
+                  </p:par>
+                </p:childTnLst>
+              </p:cTn>
+              <p:prevCondLst>
+                <p:cond evt="onPrev" delay="0">
+                  <p:tgtEl>
+                    <p:sldTgt/>
+                  </p:tgtEl>
+                </p:cond>
+              </p:prevCondLst>
+              <p:nextCondLst>
+                <p:cond evt="onNext" delay="0">
+                  <p:tgtEl>
+                    <p:sldTgt/>
+                  </p:tgtEl>
+                </p:cond>
+              </p:nextCondLst>
+            </p:seq>
+          </p:childTnLst>
+        </p:cTn>
+      </p:par>
+    </p:tnLst>
+    <p:bldLst>
+      <p:bldP spid="22" grpId="0"/>
+      <p:bldP spid="37" grpId="0"/>
+      <p:bldP spid="53" grpId="0"/>
+      <p:bldP spid="72" grpId="0"/>
+      <p:bldP spid="90" grpId="0"/>
+    </p:bldLst>
+  </p:timing>
+</p:sld>
+</file>
+
 <file path=ppt/theme/theme1.xml><?xml version="1.0" encoding="utf-8"?>
 <a:theme xmlns:a="http://schemas.openxmlformats.org/drawingml/2006/main" name="Office Theme">
   <a:themeElements>

</xml_diff>